<commit_message>
Alert doctrine: two-tier dark vessels (Going Dark 2-3h, Gone Dark >3h) and tightened STS rule
AIS silence now escalates: GOING DARK (medium) past 2h, GONE DARK (high) past 3h, replacing the single 6h ais-gap; thresholds via GOING_DARK_MINUTES / GONE_DARK_MINUTES. STS now requires both vessels under 1.2 kn within 0.3 NM, offshore and outside any designated anchorage (either vessel in an anchorage suppresses it); tunable via STS_PROXIMITY_NM / STS_SPEED_KN. Risk weights split (going-dark +20, gone-dark +35). Live-vessel ageing marks dark at 2h and evicts only well past the gone-dark tier. Simulator seeds both dark tiers and stages STS pairs so demos exercise the tighter rule. UI: 6 detector tiles + new labels.

Co-Authored-By: Claude Opus 4.8 <noreply@anthropic.com>
</commit_message>
<xml_diff>
--- a/SeaWatch-Capabilities-Brief.pptx
+++ b/SeaWatch-Capabilities-Brief.pptx
@@ -4,6 +4,9 @@
   <p:sldMasterIdLst>
     <p:sldMasterId id="2147483648" r:id="rId1"/>
   </p:sldMasterIdLst>
+  <p:notesMasterIdLst>
+    <p:notesMasterId r:id="rId18"/>
+  </p:notesMasterIdLst>
   <p:sldIdLst>
     <p:sldId id="256" r:id="rId2"/>
     <p:sldId id="257" r:id="rId3"/>
@@ -22,11 +25,8 @@
     <p:sldId id="270" r:id="rId16"/>
     <p:sldId id="271" r:id="rId17"/>
   </p:sldIdLst>
-  <p:notesMasterIdLst>
-    <p:notesMasterId r:id="rId18"/>
-  </p:notesMasterIdLst>
-  <p:sldSz cx="12191695" cy="6858000"/>
-  <p:notesSz cx="6858000" cy="12191695"/>
+  <p:sldSz cx="12192000" cy="6858000"/>
+  <p:notesSz cx="6858000" cy="12192000"/>
   <p:defaultTextStyle>
     <a:lvl1pPr marL="0" algn="l" defTabSz="914400" rtl="0" eaLnBrk="1" latinLnBrk="0" hangingPunct="1">
       <a:defRPr sz="1800" kern="1200">
@@ -119,6 +119,11 @@
       </a:defRPr>
     </a:lvl9pPr>
   </p:defaultTextStyle>
+  <p:extLst>
+    <p:ext uri="{EFAFB233-063F-42B5-8137-9DF3F51BA10A}">
+      <p15:sldGuideLst xmlns:p15="http://schemas.microsoft.com/office/powerpoint/2012/main"/>
+    </p:ext>
+  </p:extLst>
 </p:presentation>
 </file>
 
@@ -144,234 +149,10 @@
           <a:chExt cx="0" cy="0"/>
         </a:xfrm>
       </p:grpSpPr>
-      <p:sp>
-        <p:nvSpPr>
-          <p:cNvPr id="2" name="Header Placeholder 1"/>
-          <p:cNvSpPr>
-            <a:spLocks noGrp="1"/>
-          </p:cNvSpPr>
-          <p:nvPr>
-            <p:ph type="hdr" sz="quarter"/>
-          </p:nvPr>
-        </p:nvSpPr>
-        <p:spPr>
-          <a:xfrm>
-            <a:off x="0" y="0"/>
-            <a:ext cx="2971800" cy="458788"/>
-          </a:xfrm>
-          <a:prstGeom prst="rect">
-            <a:avLst/>
-          </a:prstGeom>
-        </p:spPr>
-        <p:txBody>
-          <a:bodyPr vert="horz" lIns="91440" tIns="45720" rIns="91440" bIns="45720" rtlCol="0"/>
-          <a:lstStyle>
-            <a:lvl1pPr algn="l">
-              <a:defRPr sz="1200"/>
-            </a:lvl1pPr>
-          </a:lstStyle>
-          <a:p>
-            <a:endParaRPr lang="en-US"/>
-          </a:p>
-        </p:txBody>
-      </p:sp>
-      <p:sp>
-        <p:nvSpPr>
-          <p:cNvPr id="3" name="Date Placeholder 2"/>
-          <p:cNvSpPr>
-            <a:spLocks noGrp="1"/>
-          </p:cNvSpPr>
-          <p:nvPr>
-            <p:ph type="dt" idx="1"/>
-          </p:nvPr>
-        </p:nvSpPr>
-        <p:spPr>
-          <a:xfrm>
-            <a:off x="3884613" y="0"/>
-            <a:ext cx="2971800" cy="458788"/>
-          </a:xfrm>
-          <a:prstGeom prst="rect">
-            <a:avLst/>
-          </a:prstGeom>
-        </p:spPr>
-        <p:txBody>
-          <a:bodyPr vert="horz" lIns="91440" tIns="45720" rIns="91440" bIns="45720" rtlCol="0"/>
-          <a:lstStyle>
-            <a:lvl1pPr algn="r">
-              <a:defRPr sz="1200"/>
-            </a:lvl1pPr>
-          </a:lstStyle>
-          <a:p>
-            <a:fld id="{5282F153-3F37-0F45-9E97-73ACFA13230C}" type="datetimeFigureOut">
-              <a:rPr lang="en-US"/>
-              <a:t>7/23/19</a:t>
-            </a:fld>
-            <a:endParaRPr lang="en-US"/>
-          </a:p>
-        </p:txBody>
-      </p:sp>
-      <p:sp>
-        <p:nvSpPr>
-          <p:cNvPr id="4" name="Slide Image Placeholder 3"/>
-          <p:cNvSpPr>
-            <a:spLocks noGrp="1" noRot="1" noChangeAspect="1"/>
-          </p:cNvSpPr>
-          <p:nvPr>
-            <p:ph type="sldImg" idx="2"/>
-          </p:nvPr>
-        </p:nvSpPr>
-        <p:spPr>
-          <a:xfrm>
-            <a:off x="685800" y="1143000"/>
-            <a:ext cx="5486400" cy="3086100"/>
-          </a:xfrm>
-          <a:prstGeom prst="rect">
-            <a:avLst/>
-          </a:prstGeom>
-          <a:noFill/>
-          <a:ln w="12700">
-            <a:solidFill>
-              <a:prstClr val="black"/>
-            </a:solidFill>
-          </a:ln>
-        </p:spPr>
-        <p:txBody>
-          <a:bodyPr vert="horz" lIns="91440" tIns="45720" rIns="91440" bIns="45720" rtlCol="0" anchor="ctr"/>
-          <a:lstStyle/>
-          <a:p>
-            <a:endParaRPr lang="en-US"/>
-          </a:p>
-        </p:txBody>
-      </p:sp>
-      <p:sp>
-        <p:nvSpPr>
-          <p:cNvPr id="5" name="Notes Placeholder 4"/>
-          <p:cNvSpPr>
-            <a:spLocks noGrp="1"/>
-          </p:cNvSpPr>
-          <p:nvPr>
-            <p:ph type="body" sz="quarter" idx="3"/>
-          </p:nvPr>
-        </p:nvSpPr>
-        <p:spPr>
-          <a:xfrm>
-            <a:off x="685800" y="4400550"/>
-            <a:ext cx="5486400" cy="3600450"/>
-          </a:xfrm>
-          <a:prstGeom prst="rect">
-            <a:avLst/>
-          </a:prstGeom>
-        </p:spPr>
-        <p:txBody>
-          <a:bodyPr vert="horz" lIns="91440" tIns="45720" rIns="91440" bIns="45720" rtlCol="0"/>
-          <a:lstStyle/>
-          <a:p>
-            <a:pPr lvl="0"/>
-            <a:r>
-              <a:rPr lang="en-US"/>
-              <a:t>Click to edit Master text styles</a:t>
-            </a:r>
-          </a:p>
-          <a:p>
-            <a:pPr lvl="1"/>
-            <a:r>
-              <a:rPr lang="en-US"/>
-              <a:t>Second level</a:t>
-            </a:r>
-          </a:p>
-          <a:p>
-            <a:pPr lvl="2"/>
-            <a:r>
-              <a:rPr lang="en-US"/>
-              <a:t>Third level</a:t>
-            </a:r>
-          </a:p>
-          <a:p>
-            <a:pPr lvl="3"/>
-            <a:r>
-              <a:rPr lang="en-US"/>
-              <a:t>Fourth level</a:t>
-            </a:r>
-          </a:p>
-          <a:p>
-            <a:pPr lvl="4"/>
-            <a:r>
-              <a:rPr lang="en-US"/>
-              <a:t>Fifth level</a:t>
-            </a:r>
-          </a:p>
-        </p:txBody>
-      </p:sp>
-      <p:sp>
-        <p:nvSpPr>
-          <p:cNvPr id="6" name="Footer Placeholder 5"/>
-          <p:cNvSpPr>
-            <a:spLocks noGrp="1"/>
-          </p:cNvSpPr>
-          <p:nvPr>
-            <p:ph type="ftr" sz="quarter" idx="4"/>
-          </p:nvPr>
-        </p:nvSpPr>
-        <p:spPr>
-          <a:xfrm>
-            <a:off x="0" y="8685213"/>
-            <a:ext cx="2971800" cy="458787"/>
-          </a:xfrm>
-          <a:prstGeom prst="rect">
-            <a:avLst/>
-          </a:prstGeom>
-        </p:spPr>
-        <p:txBody>
-          <a:bodyPr vert="horz" lIns="91440" tIns="45720" rIns="91440" bIns="45720" rtlCol="0" anchor="b"/>
-          <a:lstStyle>
-            <a:lvl1pPr algn="l">
-              <a:defRPr sz="1200"/>
-            </a:lvl1pPr>
-          </a:lstStyle>
-          <a:p>
-            <a:endParaRPr lang="en-US"/>
-          </a:p>
-        </p:txBody>
-      </p:sp>
-      <p:sp>
-        <p:nvSpPr>
-          <p:cNvPr id="7" name="Slide Number Placeholder 6"/>
-          <p:cNvSpPr>
-            <a:spLocks noGrp="1"/>
-          </p:cNvSpPr>
-          <p:nvPr>
-            <p:ph type="sldNum" sz="quarter" idx="5"/>
-          </p:nvPr>
-        </p:nvSpPr>
-        <p:spPr>
-          <a:xfrm>
-            <a:off x="3884613" y="8685213"/>
-            <a:ext cx="2971800" cy="458787"/>
-          </a:xfrm>
-          <a:prstGeom prst="rect">
-            <a:avLst/>
-          </a:prstGeom>
-        </p:spPr>
-        <p:txBody>
-          <a:bodyPr vert="horz" lIns="91440" tIns="45720" rIns="91440" bIns="45720" rtlCol="0" anchor="b"/>
-          <a:lstStyle>
-            <a:lvl1pPr algn="r">
-              <a:defRPr sz="1200"/>
-            </a:lvl1pPr>
-          </a:lstStyle>
-          <a:p>
-            <a:fld id="{CE5E9CC1-C706-0F49-92D6-E571CC5EEA8F}" type="slidenum">
-              <a:rPr lang="en-US"/>
-              <a:t>‹#›</a:t>
-            </a:fld>
-            <a:endParaRPr lang="en-US"/>
-          </a:p>
-        </p:txBody>
-      </p:sp>
     </p:spTree>
     <p:extLst>
       <p:ext uri="{BB962C8B-B14F-4D97-AF65-F5344CB8AC3E}">
-        <p14:creationId xmlns:p14="http://schemas.microsoft.com/office/powerpoint/2010/main" val="1024086991"/>
+        <p14:creationId xmlns:p14="http://schemas.microsoft.com/office/powerpoint/2010/main" val="3810836076"/>
       </p:ext>
     </p:extLst>
   </p:cSld>
@@ -515,10 +296,6 @@
           <a:bodyPr/>
           <a:lstStyle/>
           <a:p>
-            <a:r>
-              <a:rPr lang="en-US" dirty="0"/>
-              <a:t/>
-            </a:r>
             <a:endParaRPr lang="en-US" dirty="0"/>
           </a:p>
         </p:txBody>
@@ -603,10 +380,6 @@
           <a:bodyPr/>
           <a:lstStyle/>
           <a:p>
-            <a:r>
-              <a:rPr lang="en-US" dirty="0"/>
-              <a:t/>
-            </a:r>
             <a:endParaRPr lang="en-US" dirty="0"/>
           </a:p>
         </p:txBody>
@@ -691,10 +464,6 @@
           <a:bodyPr/>
           <a:lstStyle/>
           <a:p>
-            <a:r>
-              <a:rPr lang="en-US" dirty="0"/>
-              <a:t/>
-            </a:r>
             <a:endParaRPr lang="en-US" dirty="0"/>
           </a:p>
         </p:txBody>
@@ -779,10 +548,6 @@
           <a:bodyPr/>
           <a:lstStyle/>
           <a:p>
-            <a:r>
-              <a:rPr lang="en-US" dirty="0"/>
-              <a:t/>
-            </a:r>
             <a:endParaRPr lang="en-US" dirty="0"/>
           </a:p>
         </p:txBody>
@@ -867,10 +632,6 @@
           <a:bodyPr/>
           <a:lstStyle/>
           <a:p>
-            <a:r>
-              <a:rPr lang="en-US" dirty="0"/>
-              <a:t/>
-            </a:r>
             <a:endParaRPr lang="en-US" dirty="0"/>
           </a:p>
         </p:txBody>
@@ -955,10 +716,6 @@
           <a:bodyPr/>
           <a:lstStyle/>
           <a:p>
-            <a:r>
-              <a:rPr lang="en-US" dirty="0"/>
-              <a:t/>
-            </a:r>
             <a:endParaRPr lang="en-US" dirty="0"/>
           </a:p>
         </p:txBody>
@@ -1043,10 +800,6 @@
           <a:bodyPr/>
           <a:lstStyle/>
           <a:p>
-            <a:r>
-              <a:rPr lang="en-US" dirty="0"/>
-              <a:t/>
-            </a:r>
             <a:endParaRPr lang="en-US" dirty="0"/>
           </a:p>
         </p:txBody>
@@ -1131,10 +884,6 @@
           <a:bodyPr/>
           <a:lstStyle/>
           <a:p>
-            <a:r>
-              <a:rPr lang="en-US" dirty="0"/>
-              <a:t/>
-            </a:r>
             <a:endParaRPr lang="en-US" dirty="0"/>
           </a:p>
         </p:txBody>
@@ -1219,10 +968,6 @@
           <a:bodyPr/>
           <a:lstStyle/>
           <a:p>
-            <a:r>
-              <a:rPr lang="en-US" dirty="0"/>
-              <a:t/>
-            </a:r>
             <a:endParaRPr lang="en-US" dirty="0"/>
           </a:p>
         </p:txBody>
@@ -1307,10 +1052,6 @@
           <a:bodyPr/>
           <a:lstStyle/>
           <a:p>
-            <a:r>
-              <a:rPr lang="en-US" dirty="0"/>
-              <a:t/>
-            </a:r>
             <a:endParaRPr lang="en-US" dirty="0"/>
           </a:p>
         </p:txBody>
@@ -1395,10 +1136,6 @@
           <a:bodyPr/>
           <a:lstStyle/>
           <a:p>
-            <a:r>
-              <a:rPr lang="en-US" dirty="0"/>
-              <a:t/>
-            </a:r>
             <a:endParaRPr lang="en-US" dirty="0"/>
           </a:p>
         </p:txBody>
@@ -1483,10 +1220,6 @@
           <a:bodyPr/>
           <a:lstStyle/>
           <a:p>
-            <a:r>
-              <a:rPr lang="en-US" dirty="0"/>
-              <a:t/>
-            </a:r>
             <a:endParaRPr lang="en-US" dirty="0"/>
           </a:p>
         </p:txBody>
@@ -1571,10 +1304,6 @@
           <a:bodyPr/>
           <a:lstStyle/>
           <a:p>
-            <a:r>
-              <a:rPr lang="en-US" dirty="0"/>
-              <a:t/>
-            </a:r>
             <a:endParaRPr lang="en-US" dirty="0"/>
           </a:p>
         </p:txBody>
@@ -1659,10 +1388,6 @@
           <a:bodyPr/>
           <a:lstStyle/>
           <a:p>
-            <a:r>
-              <a:rPr lang="en-US" dirty="0"/>
-              <a:t/>
-            </a:r>
             <a:endParaRPr lang="en-US" dirty="0"/>
           </a:p>
         </p:txBody>
@@ -1747,10 +1472,6 @@
           <a:bodyPr/>
           <a:lstStyle/>
           <a:p>
-            <a:r>
-              <a:rPr lang="en-US" dirty="0"/>
-              <a:t/>
-            </a:r>
             <a:endParaRPr lang="en-US" dirty="0"/>
           </a:p>
         </p:txBody>
@@ -1835,10 +1556,6 @@
           <a:bodyPr/>
           <a:lstStyle/>
           <a:p>
-            <a:r>
-              <a:rPr lang="en-US" dirty="0"/>
-              <a:t/>
-            </a:r>
             <a:endParaRPr lang="en-US" dirty="0"/>
           </a:p>
         </p:txBody>
@@ -1912,6 +1629,11 @@
 <file path=ppt/slideMasters/slideMaster1.xml><?xml version="1.0" encoding="utf-8"?>
 <p:sldMaster xmlns:a="http://schemas.openxmlformats.org/drawingml/2006/main" xmlns:r="http://schemas.openxmlformats.org/officeDocument/2006/relationships" xmlns:p="http://schemas.openxmlformats.org/presentationml/2006/main">
   <p:cSld>
+    <p:bg>
+      <p:bgRef idx="1001">
+        <a:schemeClr val="bg1"/>
+      </p:bgRef>
+    </p:bg>
     <p:spTree>
       <p:nvGrpSpPr>
         <p:cNvPr id="1" name=""/>
@@ -2194,6 +1916,7 @@
         <a:solidFill>
           <a:srgbClr val="0A1A2E"/>
         </a:solidFill>
+        <a:effectLst/>
       </p:bgPr>
     </p:bg>
     <p:spTree>
@@ -2232,14 +1955,14 @@
       </p:sp>
       <p:pic>
         <p:nvPicPr>
-          <p:cNvPr id="3" name="Image 0" descr="crest.png">    </p:cNvPr>
+          <p:cNvPr id="3" name="Image 0" descr="crest.png"/>
           <p:cNvPicPr>
             <a:picLocks noChangeAspect="1"/>
           </p:cNvPicPr>
           <p:nvPr/>
         </p:nvPicPr>
         <p:blipFill>
-          <a:blip r:embed="rId1"/>
+          <a:blip r:embed="rId3"/>
           <a:stretch>
             <a:fillRect/>
           </a:stretch>
@@ -2275,7 +1998,7 @@
           <a:bodyPr wrap="square" lIns="0" tIns="0" rIns="0" bIns="0" rtlCol="0" anchor="ctr"/>
           <a:lstStyle/>
           <a:p>
-            <a:pPr indent="0" marL="0">
+            <a:pPr marL="0" indent="0">
               <a:buNone/>
             </a:pPr>
             <a:r>
@@ -2314,11 +2037,11 @@
           <a:bodyPr wrap="square" lIns="0" tIns="0" rIns="0" bIns="0" rtlCol="0" anchor="ctr"/>
           <a:lstStyle/>
           <a:p>
-            <a:pPr indent="0" marL="0">
-              <a:buNone/>
-            </a:pPr>
-            <a:r>
-              <a:rPr lang="en-US" sz="1500" b="1" spc="200" kern="0" dirty="0">
+            <a:pPr marL="0" indent="0">
+              <a:buNone/>
+            </a:pPr>
+            <a:r>
+              <a:rPr lang="en-US" sz="1500" b="1" kern="0" spc="200" dirty="0">
                 <a:solidFill>
                   <a:srgbClr val="F2C200"/>
                 </a:solidFill>
@@ -2376,7 +2099,7 @@
           <a:bodyPr wrap="square" lIns="0" tIns="0" rIns="0" bIns="0" rtlCol="0" anchor="ctr"/>
           <a:lstStyle/>
           <a:p>
-            <a:pPr indent="0" marL="0">
+            <a:pPr marL="0" indent="0">
               <a:buNone/>
             </a:pPr>
             <a:r>
@@ -2415,7 +2138,7 @@
           <a:bodyPr wrap="square" lIns="0" tIns="0" rIns="0" bIns="0" rtlCol="0" anchor="ctr"/>
           <a:lstStyle/>
           <a:p>
-            <a:pPr indent="0" marL="0">
+            <a:pPr marL="0" indent="0">
               <a:buNone/>
             </a:pPr>
             <a:r>
@@ -2476,7 +2199,7 @@
           <a:bodyPr wrap="square" lIns="0" tIns="0" rIns="0" bIns="0" rtlCol="0" anchor="ctr"/>
           <a:lstStyle/>
           <a:p>
-            <a:pPr algn="ctr" indent="0" marL="0">
+            <a:pPr marL="0" indent="0" algn="ctr">
               <a:buNone/>
             </a:pPr>
             <a:r>
@@ -2537,7 +2260,7 @@
           <a:bodyPr wrap="square" lIns="0" tIns="0" rIns="0" bIns="0" rtlCol="0" anchor="ctr"/>
           <a:lstStyle/>
           <a:p>
-            <a:pPr algn="ctr" indent="0" marL="0">
+            <a:pPr marL="0" indent="0" algn="ctr">
               <a:buNone/>
             </a:pPr>
             <a:r>
@@ -2598,7 +2321,7 @@
           <a:bodyPr wrap="square" lIns="0" tIns="0" rIns="0" bIns="0" rtlCol="0" anchor="ctr"/>
           <a:lstStyle/>
           <a:p>
-            <a:pPr algn="ctr" indent="0" marL="0">
+            <a:pPr marL="0" indent="0" algn="ctr">
               <a:buNone/>
             </a:pPr>
             <a:r>
@@ -2637,7 +2360,7 @@
           <a:bodyPr wrap="square" lIns="0" tIns="0" rIns="0" bIns="0" rtlCol="0" anchor="ctr"/>
           <a:lstStyle/>
           <a:p>
-            <a:pPr algn="r" indent="0" marL="0">
+            <a:pPr marL="0" indent="0" algn="r">
               <a:buNone/>
             </a:pPr>
             <a:r>
@@ -2654,7 +2377,7 @@
             <a:endParaRPr lang="en-US" sz="1150" dirty="0"/>
           </a:p>
           <a:p>
-            <a:pPr algn="r" indent="0" marL="0">
+            <a:pPr marL="0" indent="0" algn="r">
               <a:buNone/>
             </a:pPr>
             <a:r>
@@ -2688,6 +2411,7 @@
         <a:solidFill>
           <a:srgbClr val="FFFFFF"/>
         </a:solidFill>
+        <a:effectLst/>
       </p:bgPr>
     </p:bg>
     <p:spTree>
@@ -2725,11 +2449,11 @@
           <a:bodyPr wrap="square" lIns="0" tIns="0" rIns="0" bIns="0" rtlCol="0" anchor="ctr"/>
           <a:lstStyle/>
           <a:p>
-            <a:pPr indent="0" marL="0">
-              <a:buNone/>
-            </a:pPr>
-            <a:r>
-              <a:rPr lang="en-US" sz="1250" b="1" spc="200" kern="0" dirty="0">
+            <a:pPr marL="0" indent="0">
+              <a:buNone/>
+            </a:pPr>
+            <a:r>
+              <a:rPr lang="en-US" sz="1250" b="1" kern="0" spc="200" dirty="0">
                 <a:solidFill>
                   <a:srgbClr val="1B9E8A"/>
                 </a:solidFill>
@@ -2764,7 +2488,7 @@
           <a:bodyPr wrap="square" lIns="0" tIns="0" rIns="0" bIns="0" rtlCol="0" anchor="ctr"/>
           <a:lstStyle/>
           <a:p>
-            <a:pPr indent="0" marL="0">
+            <a:pPr marL="0" indent="0">
               <a:buNone/>
             </a:pPr>
             <a:r>
@@ -2803,7 +2527,7 @@
           </a:solidFill>
           <a:ln/>
           <a:effectLst>
-            <a:outerShdw sx="100000" sy="100000" kx="0" ky="0" algn="bl" rotWithShape="0" blurRad="101600" dist="38100" dir="5400000">
+            <a:outerShdw blurRad="101600" dist="38100" dir="5400000" algn="bl" rotWithShape="0">
               <a:srgbClr val="0A1626">
                 <a:alpha val="10000"/>
               </a:srgbClr>
@@ -2852,7 +2576,7 @@
           <a:bodyPr wrap="square" lIns="0" tIns="0" rIns="0" bIns="0" rtlCol="0" anchor="ctr"/>
           <a:lstStyle/>
           <a:p>
-            <a:pPr indent="0" marL="0">
+            <a:pPr marL="0" indent="0">
               <a:buNone/>
             </a:pPr>
             <a:r>
@@ -2891,7 +2615,7 @@
           <a:bodyPr wrap="square" lIns="0" tIns="0" rIns="0" bIns="0" rtlCol="0" anchor="t"/>
           <a:lstStyle/>
           <a:p>
-            <a:pPr indent="0" marL="0">
+            <a:pPr marL="0" indent="0">
               <a:buNone/>
             </a:pPr>
             <a:r>
@@ -2930,7 +2654,7 @@
           </a:solidFill>
           <a:ln/>
           <a:effectLst>
-            <a:outerShdw sx="100000" sy="100000" kx="0" ky="0" algn="bl" rotWithShape="0" blurRad="101600" dist="38100" dir="5400000">
+            <a:outerShdw blurRad="101600" dist="38100" dir="5400000" algn="bl" rotWithShape="0">
               <a:srgbClr val="0A1626">
                 <a:alpha val="10000"/>
               </a:srgbClr>
@@ -2979,7 +2703,7 @@
           <a:bodyPr wrap="square" lIns="0" tIns="0" rIns="0" bIns="0" rtlCol="0" anchor="ctr"/>
           <a:lstStyle/>
           <a:p>
-            <a:pPr indent="0" marL="0">
+            <a:pPr marL="0" indent="0">
               <a:buNone/>
             </a:pPr>
             <a:r>
@@ -3018,7 +2742,7 @@
           <a:bodyPr wrap="square" lIns="0" tIns="0" rIns="0" bIns="0" rtlCol="0" anchor="t"/>
           <a:lstStyle/>
           <a:p>
-            <a:pPr indent="0" marL="0">
+            <a:pPr marL="0" indent="0">
               <a:buNone/>
             </a:pPr>
             <a:r>
@@ -3057,7 +2781,7 @@
           </a:solidFill>
           <a:ln/>
           <a:effectLst>
-            <a:outerShdw sx="100000" sy="100000" kx="0" ky="0" algn="bl" rotWithShape="0" blurRad="101600" dist="38100" dir="5400000">
+            <a:outerShdw blurRad="101600" dist="38100" dir="5400000" algn="bl" rotWithShape="0">
               <a:srgbClr val="0A1626">
                 <a:alpha val="10000"/>
               </a:srgbClr>
@@ -3106,7 +2830,7 @@
           <a:bodyPr wrap="square" lIns="0" tIns="0" rIns="0" bIns="0" rtlCol="0" anchor="ctr"/>
           <a:lstStyle/>
           <a:p>
-            <a:pPr indent="0" marL="0">
+            <a:pPr marL="0" indent="0">
               <a:buNone/>
             </a:pPr>
             <a:r>
@@ -3145,7 +2869,7 @@
           <a:bodyPr wrap="square" lIns="0" tIns="0" rIns="0" bIns="0" rtlCol="0" anchor="t"/>
           <a:lstStyle/>
           <a:p>
-            <a:pPr indent="0" marL="0">
+            <a:pPr marL="0" indent="0">
               <a:buNone/>
             </a:pPr>
             <a:r>
@@ -3184,7 +2908,7 @@
           </a:solidFill>
           <a:ln/>
           <a:effectLst>
-            <a:outerShdw sx="100000" sy="100000" kx="0" ky="0" algn="bl" rotWithShape="0" blurRad="101600" dist="38100" dir="5400000">
+            <a:outerShdw blurRad="101600" dist="38100" dir="5400000" algn="bl" rotWithShape="0">
               <a:srgbClr val="0A1626">
                 <a:alpha val="10000"/>
               </a:srgbClr>
@@ -3233,7 +2957,7 @@
           <a:bodyPr wrap="square" lIns="0" tIns="0" rIns="0" bIns="0" rtlCol="0" anchor="ctr"/>
           <a:lstStyle/>
           <a:p>
-            <a:pPr indent="0" marL="0">
+            <a:pPr marL="0" indent="0">
               <a:buNone/>
             </a:pPr>
             <a:r>
@@ -3272,7 +2996,7 @@
           <a:bodyPr wrap="square" lIns="0" tIns="0" rIns="0" bIns="0" rtlCol="0" anchor="t"/>
           <a:lstStyle/>
           <a:p>
-            <a:pPr indent="0" marL="0">
+            <a:pPr marL="0" indent="0">
               <a:buNone/>
             </a:pPr>
             <a:r>
@@ -3311,7 +3035,7 @@
           <a:bodyPr wrap="square" lIns="0" tIns="0" rIns="0" bIns="0" rtlCol="0" anchor="ctr"/>
           <a:lstStyle/>
           <a:p>
-            <a:pPr indent="0" marL="0">
+            <a:pPr marL="0" indent="0">
               <a:buNone/>
             </a:pPr>
             <a:r>
@@ -3350,7 +3074,7 @@
           <a:bodyPr wrap="square" lIns="0" tIns="0" rIns="0" bIns="0" rtlCol="0" anchor="ctr"/>
           <a:lstStyle/>
           <a:p>
-            <a:pPr indent="0" marL="0">
+            <a:pPr marL="0" indent="0">
               <a:buNone/>
             </a:pPr>
             <a:r>
@@ -3364,9 +3088,6 @@
               </a:rPr>
               <a:t>SeaWatch</a:t>
             </a:r>
-            <a:pPr indent="0" marL="0">
-              <a:buNone/>
-            </a:pPr>
             <a:r>
               <a:rPr lang="en-US" sz="900" dirty="0">
                 <a:solidFill>
@@ -3403,7 +3124,7 @@
           <a:bodyPr wrap="square" rtlCol="0" anchor="ctr"/>
           <a:lstStyle/>
           <a:p>
-            <a:pPr algn="r" indent="0" marL="0">
+            <a:pPr marL="0" indent="0" algn="r">
               <a:buNone/>
             </a:pPr>
             <a:r>
@@ -3437,6 +3158,7 @@
         <a:solidFill>
           <a:srgbClr val="FFFFFF"/>
         </a:solidFill>
+        <a:effectLst/>
       </p:bgPr>
     </p:bg>
     <p:spTree>
@@ -3474,11 +3196,11 @@
           <a:bodyPr wrap="square" lIns="0" tIns="0" rIns="0" bIns="0" rtlCol="0" anchor="ctr"/>
           <a:lstStyle/>
           <a:p>
-            <a:pPr indent="0" marL="0">
-              <a:buNone/>
-            </a:pPr>
-            <a:r>
-              <a:rPr lang="en-US" sz="1250" b="1" spc="200" kern="0" dirty="0">
+            <a:pPr marL="0" indent="0">
+              <a:buNone/>
+            </a:pPr>
+            <a:r>
+              <a:rPr lang="en-US" sz="1250" b="1" kern="0" spc="200" dirty="0">
                 <a:solidFill>
                   <a:srgbClr val="2E6FB0"/>
                 </a:solidFill>
@@ -3513,7 +3235,7 @@
           <a:bodyPr wrap="square" lIns="0" tIns="0" rIns="0" bIns="0" rtlCol="0" anchor="ctr"/>
           <a:lstStyle/>
           <a:p>
-            <a:pPr indent="0" marL="0">
+            <a:pPr marL="0" indent="0">
               <a:buNone/>
             </a:pPr>
             <a:r>
@@ -3552,11 +3274,11 @@
           <a:bodyPr wrap="square" lIns="0" tIns="0" rIns="0" bIns="0" rtlCol="0" anchor="ctr"/>
           <a:lstStyle/>
           <a:p>
-            <a:pPr indent="0" marL="0">
-              <a:buNone/>
-            </a:pPr>
-            <a:r>
-              <a:rPr lang="en-US" sz="1250" b="1" spc="100" kern="0" dirty="0">
+            <a:pPr marL="0" indent="0">
+              <a:buNone/>
+            </a:pPr>
+            <a:r>
+              <a:rPr lang="en-US" sz="1250" b="1" kern="0" spc="100" dirty="0">
                 <a:solidFill>
                   <a:srgbClr val="13263B"/>
                 </a:solidFill>
@@ -3591,7 +3313,7 @@
           </a:solidFill>
           <a:ln/>
           <a:effectLst>
-            <a:outerShdw sx="100000" sy="100000" kx="0" ky="0" algn="bl" rotWithShape="0" blurRad="101600" dist="38100" dir="5400000">
+            <a:outerShdw blurRad="101600" dist="38100" dir="5400000" algn="bl" rotWithShape="0">
               <a:srgbClr val="0A1626">
                 <a:alpha val="10000"/>
               </a:srgbClr>
@@ -3620,7 +3342,7 @@
           <a:bodyPr wrap="square" lIns="0" tIns="0" rIns="0" bIns="0" rtlCol="0" anchor="ctr"/>
           <a:lstStyle/>
           <a:p>
-            <a:pPr indent="0" marL="0">
+            <a:pPr marL="0" indent="0">
               <a:buNone/>
             </a:pPr>
             <a:r>
@@ -3659,7 +3381,7 @@
           <a:bodyPr wrap="square" lIns="0" tIns="0" rIns="0" bIns="0" rtlCol="0" anchor="ctr"/>
           <a:lstStyle/>
           <a:p>
-            <a:pPr indent="0" marL="0">
+            <a:pPr marL="0" indent="0">
               <a:buNone/>
             </a:pPr>
             <a:r>
@@ -3698,7 +3420,7 @@
           </a:solidFill>
           <a:ln/>
           <a:effectLst>
-            <a:outerShdw sx="100000" sy="100000" kx="0" ky="0" algn="bl" rotWithShape="0" blurRad="101600" dist="38100" dir="5400000">
+            <a:outerShdw blurRad="101600" dist="38100" dir="5400000" algn="bl" rotWithShape="0">
               <a:srgbClr val="0A1626">
                 <a:alpha val="10000"/>
               </a:srgbClr>
@@ -3727,7 +3449,7 @@
           <a:bodyPr wrap="square" lIns="0" tIns="0" rIns="0" bIns="0" rtlCol="0" anchor="ctr"/>
           <a:lstStyle/>
           <a:p>
-            <a:pPr indent="0" marL="0">
+            <a:pPr marL="0" indent="0">
               <a:buNone/>
             </a:pPr>
             <a:r>
@@ -3766,7 +3488,7 @@
           <a:bodyPr wrap="square" lIns="0" tIns="0" rIns="0" bIns="0" rtlCol="0" anchor="ctr"/>
           <a:lstStyle/>
           <a:p>
-            <a:pPr indent="0" marL="0">
+            <a:pPr marL="0" indent="0">
               <a:buNone/>
             </a:pPr>
             <a:r>
@@ -3805,7 +3527,7 @@
           </a:solidFill>
           <a:ln/>
           <a:effectLst>
-            <a:outerShdw sx="100000" sy="100000" kx="0" ky="0" algn="bl" rotWithShape="0" blurRad="101600" dist="38100" dir="5400000">
+            <a:outerShdw blurRad="101600" dist="38100" dir="5400000" algn="bl" rotWithShape="0">
               <a:srgbClr val="0A1626">
                 <a:alpha val="10000"/>
               </a:srgbClr>
@@ -3834,7 +3556,7 @@
           <a:bodyPr wrap="square" lIns="0" tIns="0" rIns="0" bIns="0" rtlCol="0" anchor="ctr"/>
           <a:lstStyle/>
           <a:p>
-            <a:pPr indent="0" marL="0">
+            <a:pPr marL="0" indent="0">
               <a:buNone/>
             </a:pPr>
             <a:r>
@@ -3873,7 +3595,7 @@
           <a:bodyPr wrap="square" lIns="0" tIns="0" rIns="0" bIns="0" rtlCol="0" anchor="ctr"/>
           <a:lstStyle/>
           <a:p>
-            <a:pPr indent="0" marL="0">
+            <a:pPr marL="0" indent="0">
               <a:buNone/>
             </a:pPr>
             <a:r>
@@ -3912,7 +3634,7 @@
           </a:solidFill>
           <a:ln/>
           <a:effectLst>
-            <a:outerShdw sx="100000" sy="100000" kx="0" ky="0" algn="bl" rotWithShape="0" blurRad="101600" dist="38100" dir="5400000">
+            <a:outerShdw blurRad="101600" dist="38100" dir="5400000" algn="bl" rotWithShape="0">
               <a:srgbClr val="0A1626">
                 <a:alpha val="10000"/>
               </a:srgbClr>
@@ -3941,7 +3663,7 @@
           <a:bodyPr wrap="square" lIns="0" tIns="0" rIns="0" bIns="0" rtlCol="0" anchor="ctr"/>
           <a:lstStyle/>
           <a:p>
-            <a:pPr indent="0" marL="0">
+            <a:pPr marL="0" indent="0">
               <a:buNone/>
             </a:pPr>
             <a:r>
@@ -3980,7 +3702,7 @@
           <a:bodyPr wrap="square" lIns="0" tIns="0" rIns="0" bIns="0" rtlCol="0" anchor="ctr"/>
           <a:lstStyle/>
           <a:p>
-            <a:pPr indent="0" marL="0">
+            <a:pPr marL="0" indent="0">
               <a:buNone/>
             </a:pPr>
             <a:r>
@@ -4019,7 +3741,7 @@
           </a:solidFill>
           <a:ln/>
           <a:effectLst>
-            <a:outerShdw sx="100000" sy="100000" kx="0" ky="0" algn="bl" rotWithShape="0" blurRad="101600" dist="38100" dir="5400000">
+            <a:outerShdw blurRad="101600" dist="38100" dir="5400000" algn="bl" rotWithShape="0">
               <a:srgbClr val="0A1626">
                 <a:alpha val="10000"/>
               </a:srgbClr>
@@ -4048,7 +3770,7 @@
           <a:bodyPr wrap="square" lIns="0" tIns="0" rIns="0" bIns="0" rtlCol="0" anchor="ctr"/>
           <a:lstStyle/>
           <a:p>
-            <a:pPr indent="0" marL="0">
+            <a:pPr marL="0" indent="0">
               <a:buNone/>
             </a:pPr>
             <a:r>
@@ -4087,7 +3809,7 @@
           <a:bodyPr wrap="square" lIns="0" tIns="0" rIns="0" bIns="0" rtlCol="0" anchor="ctr"/>
           <a:lstStyle/>
           <a:p>
-            <a:pPr indent="0" marL="0">
+            <a:pPr marL="0" indent="0">
               <a:buNone/>
             </a:pPr>
             <a:r>
@@ -4126,7 +3848,7 @@
           </a:solidFill>
           <a:ln/>
           <a:effectLst>
-            <a:outerShdw sx="100000" sy="100000" kx="0" ky="0" algn="bl" rotWithShape="0" blurRad="101600" dist="38100" dir="5400000">
+            <a:outerShdw blurRad="101600" dist="38100" dir="5400000" algn="bl" rotWithShape="0">
               <a:srgbClr val="0A1626">
                 <a:alpha val="10000"/>
               </a:srgbClr>
@@ -4155,7 +3877,7 @@
           <a:bodyPr wrap="square" lIns="0" tIns="0" rIns="0" bIns="0" rtlCol="0" anchor="ctr"/>
           <a:lstStyle/>
           <a:p>
-            <a:pPr indent="0" marL="0">
+            <a:pPr marL="0" indent="0">
               <a:buNone/>
             </a:pPr>
             <a:r>
@@ -4194,7 +3916,7 @@
           <a:bodyPr wrap="square" lIns="0" tIns="0" rIns="0" bIns="0" rtlCol="0" anchor="t"/>
           <a:lstStyle/>
           <a:p>
-            <a:pPr indent="0" marL="0">
+            <a:pPr marL="0" indent="0">
               <a:buNone/>
             </a:pPr>
             <a:r>
@@ -4233,7 +3955,7 @@
           </a:solidFill>
           <a:ln/>
           <a:effectLst>
-            <a:outerShdw sx="100000" sy="100000" kx="0" ky="0" algn="bl" rotWithShape="0" blurRad="101600" dist="38100" dir="5400000">
+            <a:outerShdw blurRad="101600" dist="38100" dir="5400000" algn="bl" rotWithShape="0">
               <a:srgbClr val="0A1626">
                 <a:alpha val="10000"/>
               </a:srgbClr>
@@ -4262,7 +3984,7 @@
           <a:bodyPr wrap="square" lIns="0" tIns="0" rIns="0" bIns="0" rtlCol="0" anchor="ctr"/>
           <a:lstStyle/>
           <a:p>
-            <a:pPr indent="0" marL="0">
+            <a:pPr marL="0" indent="0">
               <a:buNone/>
             </a:pPr>
             <a:r>
@@ -4301,7 +4023,7 @@
           <a:bodyPr wrap="square" lIns="0" tIns="0" rIns="0" bIns="0" rtlCol="0" anchor="t"/>
           <a:lstStyle/>
           <a:p>
-            <a:pPr indent="0" marL="0">
+            <a:pPr marL="0" indent="0">
               <a:buNone/>
             </a:pPr>
             <a:r>
@@ -4340,7 +4062,7 @@
           </a:solidFill>
           <a:ln/>
           <a:effectLst>
-            <a:outerShdw sx="100000" sy="100000" kx="0" ky="0" algn="bl" rotWithShape="0" blurRad="101600" dist="38100" dir="5400000">
+            <a:outerShdw blurRad="101600" dist="38100" dir="5400000" algn="bl" rotWithShape="0">
               <a:srgbClr val="0A1626">
                 <a:alpha val="10000"/>
               </a:srgbClr>
@@ -4369,7 +4091,7 @@
           <a:bodyPr wrap="square" lIns="0" tIns="0" rIns="0" bIns="0" rtlCol="0" anchor="ctr"/>
           <a:lstStyle/>
           <a:p>
-            <a:pPr indent="0" marL="0">
+            <a:pPr marL="0" indent="0">
               <a:buNone/>
             </a:pPr>
             <a:r>
@@ -4408,7 +4130,7 @@
           <a:bodyPr wrap="square" lIns="0" tIns="0" rIns="0" bIns="0" rtlCol="0" anchor="t"/>
           <a:lstStyle/>
           <a:p>
-            <a:pPr indent="0" marL="0">
+            <a:pPr marL="0" indent="0">
               <a:buNone/>
             </a:pPr>
             <a:r>
@@ -4447,7 +4169,7 @@
           </a:solidFill>
           <a:ln/>
           <a:effectLst>
-            <a:outerShdw sx="100000" sy="100000" kx="0" ky="0" algn="bl" rotWithShape="0" blurRad="101600" dist="38100" dir="5400000">
+            <a:outerShdw blurRad="101600" dist="38100" dir="5400000" algn="bl" rotWithShape="0">
               <a:srgbClr val="0A1626">
                 <a:alpha val="10000"/>
               </a:srgbClr>
@@ -4476,7 +4198,7 @@
           <a:bodyPr wrap="square" lIns="0" tIns="0" rIns="0" bIns="0" rtlCol="0" anchor="ctr"/>
           <a:lstStyle/>
           <a:p>
-            <a:pPr indent="0" marL="0">
+            <a:pPr marL="0" indent="0">
               <a:buNone/>
             </a:pPr>
             <a:r>
@@ -4515,7 +4237,7 @@
           <a:bodyPr wrap="square" lIns="0" tIns="0" rIns="0" bIns="0" rtlCol="0" anchor="t"/>
           <a:lstStyle/>
           <a:p>
-            <a:pPr indent="0" marL="0">
+            <a:pPr marL="0" indent="0">
               <a:buNone/>
             </a:pPr>
             <a:r>
@@ -4554,7 +4276,7 @@
           <a:bodyPr wrap="square" lIns="0" tIns="0" rIns="0" bIns="0" rtlCol="0" anchor="ctr"/>
           <a:lstStyle/>
           <a:p>
-            <a:pPr indent="0" marL="0">
+            <a:pPr marL="0" indent="0">
               <a:buNone/>
             </a:pPr>
             <a:r>
@@ -4568,9 +4290,6 @@
               </a:rPr>
               <a:t>SeaWatch</a:t>
             </a:r>
-            <a:pPr indent="0" marL="0">
-              <a:buNone/>
-            </a:pPr>
             <a:r>
               <a:rPr lang="en-US" sz="900" dirty="0">
                 <a:solidFill>
@@ -4607,7 +4326,7 @@
           <a:bodyPr wrap="square" rtlCol="0" anchor="ctr"/>
           <a:lstStyle/>
           <a:p>
-            <a:pPr algn="r" indent="0" marL="0">
+            <a:pPr marL="0" indent="0" algn="r">
               <a:buNone/>
             </a:pPr>
             <a:r>
@@ -4641,6 +4360,7 @@
         <a:solidFill>
           <a:srgbClr val="FFFFFF"/>
         </a:solidFill>
+        <a:effectLst/>
       </p:bgPr>
     </p:bg>
     <p:spTree>
@@ -4678,11 +4398,11 @@
           <a:bodyPr wrap="square" lIns="0" tIns="0" rIns="0" bIns="0" rtlCol="0" anchor="ctr"/>
           <a:lstStyle/>
           <a:p>
-            <a:pPr indent="0" marL="0">
-              <a:buNone/>
-            </a:pPr>
-            <a:r>
-              <a:rPr lang="en-US" sz="1250" b="1" spc="200" kern="0" dirty="0">
+            <a:pPr marL="0" indent="0">
+              <a:buNone/>
+            </a:pPr>
+            <a:r>
+              <a:rPr lang="en-US" sz="1250" b="1" kern="0" spc="200" dirty="0">
                 <a:solidFill>
                   <a:srgbClr val="F2C200"/>
                 </a:solidFill>
@@ -4717,7 +4437,7 @@
           <a:bodyPr wrap="square" lIns="0" tIns="0" rIns="0" bIns="0" rtlCol="0" anchor="ctr"/>
           <a:lstStyle/>
           <a:p>
-            <a:pPr indent="0" marL="0">
+            <a:pPr marL="0" indent="0">
               <a:buNone/>
             </a:pPr>
             <a:r>
@@ -4756,7 +4476,7 @@
           </a:solidFill>
           <a:ln/>
           <a:effectLst>
-            <a:outerShdw sx="100000" sy="100000" kx="0" ky="0" algn="bl" rotWithShape="0" blurRad="101600" dist="38100" dir="5400000">
+            <a:outerShdw blurRad="101600" dist="38100" dir="5400000" algn="bl" rotWithShape="0">
               <a:srgbClr val="0A1626">
                 <a:alpha val="10000"/>
               </a:srgbClr>
@@ -4783,7 +4503,7 @@
           </a:solidFill>
           <a:ln/>
           <a:effectLst>
-            <a:outerShdw sx="100000" sy="100000" kx="0" ky="0" algn="bl" rotWithShape="0" blurRad="76200" dist="25400" dir="5400000">
+            <a:outerShdw blurRad="76200" dist="25400" dir="5400000" algn="bl" rotWithShape="0">
               <a:srgbClr val="0A1626">
                 <a:alpha val="18000"/>
               </a:srgbClr>
@@ -4812,7 +4532,7 @@
           <a:bodyPr wrap="square" lIns="0" tIns="0" rIns="0" bIns="0" rtlCol="0" anchor="ctr"/>
           <a:lstStyle/>
           <a:p>
-            <a:pPr algn="ctr" indent="0" marL="0">
+            <a:pPr marL="0" indent="0" algn="ctr">
               <a:buNone/>
             </a:pPr>
             <a:r>
@@ -4851,7 +4571,7 @@
           <a:bodyPr wrap="square" lIns="0" tIns="0" rIns="0" bIns="0" rtlCol="0" anchor="ctr"/>
           <a:lstStyle/>
           <a:p>
-            <a:pPr indent="0" marL="0">
+            <a:pPr marL="0" indent="0">
               <a:buNone/>
             </a:pPr>
             <a:r>
@@ -4890,7 +4610,7 @@
           <a:bodyPr wrap="square" lIns="0" tIns="0" rIns="0" bIns="0" rtlCol="0" anchor="t"/>
           <a:lstStyle/>
           <a:p>
-            <a:pPr indent="0" marL="0">
+            <a:pPr marL="0" indent="0">
               <a:buNone/>
             </a:pPr>
             <a:r>
@@ -4929,7 +4649,7 @@
           </a:solidFill>
           <a:ln/>
           <a:effectLst>
-            <a:outerShdw sx="100000" sy="100000" kx="0" ky="0" algn="bl" rotWithShape="0" blurRad="101600" dist="38100" dir="5400000">
+            <a:outerShdw blurRad="101600" dist="38100" dir="5400000" algn="bl" rotWithShape="0">
               <a:srgbClr val="0A1626">
                 <a:alpha val="10000"/>
               </a:srgbClr>
@@ -4956,7 +4676,7 @@
           </a:solidFill>
           <a:ln/>
           <a:effectLst>
-            <a:outerShdw sx="100000" sy="100000" kx="0" ky="0" algn="bl" rotWithShape="0" blurRad="76200" dist="25400" dir="5400000">
+            <a:outerShdw blurRad="76200" dist="25400" dir="5400000" algn="bl" rotWithShape="0">
               <a:srgbClr val="0A1626">
                 <a:alpha val="18000"/>
               </a:srgbClr>
@@ -4985,7 +4705,7 @@
           <a:bodyPr wrap="square" lIns="0" tIns="0" rIns="0" bIns="0" rtlCol="0" anchor="ctr"/>
           <a:lstStyle/>
           <a:p>
-            <a:pPr algn="ctr" indent="0" marL="0">
+            <a:pPr marL="0" indent="0" algn="ctr">
               <a:buNone/>
             </a:pPr>
             <a:r>
@@ -5024,7 +4744,7 @@
           <a:bodyPr wrap="square" lIns="0" tIns="0" rIns="0" bIns="0" rtlCol="0" anchor="ctr"/>
           <a:lstStyle/>
           <a:p>
-            <a:pPr indent="0" marL="0">
+            <a:pPr marL="0" indent="0">
               <a:buNone/>
             </a:pPr>
             <a:r>
@@ -5063,7 +4783,7 @@
           <a:bodyPr wrap="square" lIns="0" tIns="0" rIns="0" bIns="0" rtlCol="0" anchor="t"/>
           <a:lstStyle/>
           <a:p>
-            <a:pPr indent="0" marL="0">
+            <a:pPr marL="0" indent="0">
               <a:buNone/>
             </a:pPr>
             <a:r>
@@ -5102,7 +4822,7 @@
           </a:solidFill>
           <a:ln/>
           <a:effectLst>
-            <a:outerShdw sx="100000" sy="100000" kx="0" ky="0" algn="bl" rotWithShape="0" blurRad="101600" dist="38100" dir="5400000">
+            <a:outerShdw blurRad="101600" dist="38100" dir="5400000" algn="bl" rotWithShape="0">
               <a:srgbClr val="0A1626">
                 <a:alpha val="10000"/>
               </a:srgbClr>
@@ -5129,7 +4849,7 @@
           </a:solidFill>
           <a:ln/>
           <a:effectLst>
-            <a:outerShdw sx="100000" sy="100000" kx="0" ky="0" algn="bl" rotWithShape="0" blurRad="76200" dist="25400" dir="5400000">
+            <a:outerShdw blurRad="76200" dist="25400" dir="5400000" algn="bl" rotWithShape="0">
               <a:srgbClr val="0A1626">
                 <a:alpha val="18000"/>
               </a:srgbClr>
@@ -5158,7 +4878,7 @@
           <a:bodyPr wrap="square" lIns="0" tIns="0" rIns="0" bIns="0" rtlCol="0" anchor="ctr"/>
           <a:lstStyle/>
           <a:p>
-            <a:pPr algn="ctr" indent="0" marL="0">
+            <a:pPr marL="0" indent="0" algn="ctr">
               <a:buNone/>
             </a:pPr>
             <a:r>
@@ -5197,7 +4917,7 @@
           <a:bodyPr wrap="square" lIns="0" tIns="0" rIns="0" bIns="0" rtlCol="0" anchor="ctr"/>
           <a:lstStyle/>
           <a:p>
-            <a:pPr indent="0" marL="0">
+            <a:pPr marL="0" indent="0">
               <a:buNone/>
             </a:pPr>
             <a:r>
@@ -5236,7 +4956,7 @@
           <a:bodyPr wrap="square" lIns="0" tIns="0" rIns="0" bIns="0" rtlCol="0" anchor="t"/>
           <a:lstStyle/>
           <a:p>
-            <a:pPr indent="0" marL="0">
+            <a:pPr marL="0" indent="0">
               <a:buNone/>
             </a:pPr>
             <a:r>
@@ -5275,7 +4995,7 @@
           </a:solidFill>
           <a:ln/>
           <a:effectLst>
-            <a:outerShdw sx="100000" sy="100000" kx="0" ky="0" algn="bl" rotWithShape="0" blurRad="101600" dist="38100" dir="5400000">
+            <a:outerShdw blurRad="101600" dist="38100" dir="5400000" algn="bl" rotWithShape="0">
               <a:srgbClr val="0A1626">
                 <a:alpha val="10000"/>
               </a:srgbClr>
@@ -5302,7 +5022,7 @@
           </a:solidFill>
           <a:ln/>
           <a:effectLst>
-            <a:outerShdw sx="100000" sy="100000" kx="0" ky="0" algn="bl" rotWithShape="0" blurRad="76200" dist="25400" dir="5400000">
+            <a:outerShdw blurRad="76200" dist="25400" dir="5400000" algn="bl" rotWithShape="0">
               <a:srgbClr val="0A1626">
                 <a:alpha val="18000"/>
               </a:srgbClr>
@@ -5331,7 +5051,7 @@
           <a:bodyPr wrap="square" lIns="0" tIns="0" rIns="0" bIns="0" rtlCol="0" anchor="ctr"/>
           <a:lstStyle/>
           <a:p>
-            <a:pPr algn="ctr" indent="0" marL="0">
+            <a:pPr marL="0" indent="0" algn="ctr">
               <a:buNone/>
             </a:pPr>
             <a:r>
@@ -5370,7 +5090,7 @@
           <a:bodyPr wrap="square" lIns="0" tIns="0" rIns="0" bIns="0" rtlCol="0" anchor="ctr"/>
           <a:lstStyle/>
           <a:p>
-            <a:pPr indent="0" marL="0">
+            <a:pPr marL="0" indent="0">
               <a:buNone/>
             </a:pPr>
             <a:r>
@@ -5409,7 +5129,7 @@
           <a:bodyPr wrap="square" lIns="0" tIns="0" rIns="0" bIns="0" rtlCol="0" anchor="t"/>
           <a:lstStyle/>
           <a:p>
-            <a:pPr indent="0" marL="0">
+            <a:pPr marL="0" indent="0">
               <a:buNone/>
             </a:pPr>
             <a:r>
@@ -5448,7 +5168,7 @@
           <a:bodyPr wrap="square" lIns="0" tIns="0" rIns="0" bIns="0" rtlCol="0" anchor="ctr"/>
           <a:lstStyle/>
           <a:p>
-            <a:pPr indent="0" marL="0">
+            <a:pPr marL="0" indent="0">
               <a:buNone/>
             </a:pPr>
             <a:r>
@@ -5462,9 +5182,6 @@
               </a:rPr>
               <a:t>SeaWatch</a:t>
             </a:r>
-            <a:pPr indent="0" marL="0">
-              <a:buNone/>
-            </a:pPr>
             <a:r>
               <a:rPr lang="en-US" sz="900" dirty="0">
                 <a:solidFill>
@@ -5501,7 +5218,7 @@
           <a:bodyPr wrap="square" rtlCol="0" anchor="ctr"/>
           <a:lstStyle/>
           <a:p>
-            <a:pPr algn="r" indent="0" marL="0">
+            <a:pPr marL="0" indent="0" algn="r">
               <a:buNone/>
             </a:pPr>
             <a:r>
@@ -5535,6 +5252,7 @@
         <a:solidFill>
           <a:srgbClr val="FFFFFF"/>
         </a:solidFill>
+        <a:effectLst/>
       </p:bgPr>
     </p:bg>
     <p:spTree>
@@ -5572,11 +5290,11 @@
           <a:bodyPr wrap="square" lIns="0" tIns="0" rIns="0" bIns="0" rtlCol="0" anchor="ctr"/>
           <a:lstStyle/>
           <a:p>
-            <a:pPr indent="0" marL="0">
-              <a:buNone/>
-            </a:pPr>
-            <a:r>
-              <a:rPr lang="en-US" sz="1250" b="1" spc="200" kern="0" dirty="0">
+            <a:pPr marL="0" indent="0">
+              <a:buNone/>
+            </a:pPr>
+            <a:r>
+              <a:rPr lang="en-US" sz="1250" b="1" kern="0" spc="200" dirty="0">
                 <a:solidFill>
                   <a:srgbClr val="2E6FB0"/>
                 </a:solidFill>
@@ -5611,7 +5329,7 @@
           <a:bodyPr wrap="square" lIns="0" tIns="0" rIns="0" bIns="0" rtlCol="0" anchor="ctr"/>
           <a:lstStyle/>
           <a:p>
-            <a:pPr indent="0" marL="0">
+            <a:pPr marL="0" indent="0">
               <a:buNone/>
             </a:pPr>
             <a:r>
@@ -5650,7 +5368,7 @@
           </a:solidFill>
           <a:ln/>
           <a:effectLst>
-            <a:outerShdw sx="100000" sy="100000" kx="0" ky="0" algn="bl" rotWithShape="0" blurRad="101600" dist="38100" dir="5400000">
+            <a:outerShdw blurRad="101600" dist="38100" dir="5400000" algn="bl" rotWithShape="0">
               <a:srgbClr val="0A1626">
                 <a:alpha val="10000"/>
               </a:srgbClr>
@@ -5679,7 +5397,7 @@
           <a:bodyPr wrap="square" lIns="0" tIns="0" rIns="0" bIns="0" rtlCol="0" anchor="ctr"/>
           <a:lstStyle/>
           <a:p>
-            <a:pPr indent="0" marL="0">
+            <a:pPr marL="0" indent="0">
               <a:buNone/>
             </a:pPr>
             <a:r>
@@ -5718,7 +5436,7 @@
           <a:bodyPr wrap="square" lIns="0" tIns="0" rIns="0" bIns="0" rtlCol="0" anchor="ctr"/>
           <a:lstStyle/>
           <a:p>
-            <a:pPr indent="0" marL="0">
+            <a:pPr marL="0" indent="0">
               <a:buNone/>
             </a:pPr>
             <a:r>
@@ -5757,7 +5475,7 @@
           </a:solidFill>
           <a:ln/>
           <a:effectLst>
-            <a:outerShdw sx="100000" sy="100000" kx="0" ky="0" algn="bl" rotWithShape="0" blurRad="101600" dist="38100" dir="5400000">
+            <a:outerShdw blurRad="101600" dist="38100" dir="5400000" algn="bl" rotWithShape="0">
               <a:srgbClr val="0A1626">
                 <a:alpha val="10000"/>
               </a:srgbClr>
@@ -5786,7 +5504,7 @@
           <a:bodyPr wrap="square" lIns="0" tIns="0" rIns="0" bIns="0" rtlCol="0" anchor="ctr"/>
           <a:lstStyle/>
           <a:p>
-            <a:pPr indent="0" marL="0">
+            <a:pPr marL="0" indent="0">
               <a:buNone/>
             </a:pPr>
             <a:r>
@@ -5825,7 +5543,7 @@
           <a:bodyPr wrap="square" lIns="0" tIns="0" rIns="0" bIns="0" rtlCol="0" anchor="ctr"/>
           <a:lstStyle/>
           <a:p>
-            <a:pPr indent="0" marL="0">
+            <a:pPr marL="0" indent="0">
               <a:buNone/>
             </a:pPr>
             <a:r>
@@ -5864,7 +5582,7 @@
           </a:solidFill>
           <a:ln/>
           <a:effectLst>
-            <a:outerShdw sx="100000" sy="100000" kx="0" ky="0" algn="bl" rotWithShape="0" blurRad="101600" dist="38100" dir="5400000">
+            <a:outerShdw blurRad="101600" dist="38100" dir="5400000" algn="bl" rotWithShape="0">
               <a:srgbClr val="0A1626">
                 <a:alpha val="10000"/>
               </a:srgbClr>
@@ -5893,7 +5611,7 @@
           <a:bodyPr wrap="square" lIns="0" tIns="0" rIns="0" bIns="0" rtlCol="0" anchor="ctr"/>
           <a:lstStyle/>
           <a:p>
-            <a:pPr indent="0" marL="0">
+            <a:pPr marL="0" indent="0">
               <a:buNone/>
             </a:pPr>
             <a:r>
@@ -5932,7 +5650,7 @@
           <a:bodyPr wrap="square" lIns="0" tIns="0" rIns="0" bIns="0" rtlCol="0" anchor="ctr"/>
           <a:lstStyle/>
           <a:p>
-            <a:pPr indent="0" marL="0">
+            <a:pPr marL="0" indent="0">
               <a:buNone/>
             </a:pPr>
             <a:r>
@@ -5971,7 +5689,7 @@
           </a:solidFill>
           <a:ln/>
           <a:effectLst>
-            <a:outerShdw sx="100000" sy="100000" kx="0" ky="0" algn="bl" rotWithShape="0" blurRad="101600" dist="38100" dir="5400000">
+            <a:outerShdw blurRad="101600" dist="38100" dir="5400000" algn="bl" rotWithShape="0">
               <a:srgbClr val="0A1626">
                 <a:alpha val="10000"/>
               </a:srgbClr>
@@ -6000,7 +5718,7 @@
           <a:bodyPr wrap="square" lIns="0" tIns="0" rIns="0" bIns="0" rtlCol="0" anchor="ctr"/>
           <a:lstStyle/>
           <a:p>
-            <a:pPr indent="0" marL="0">
+            <a:pPr marL="0" indent="0">
               <a:buNone/>
             </a:pPr>
             <a:r>
@@ -6039,7 +5757,7 @@
           <a:bodyPr wrap="square" lIns="0" tIns="0" rIns="0" bIns="0" rtlCol="0" anchor="ctr"/>
           <a:lstStyle/>
           <a:p>
-            <a:pPr indent="0" marL="0">
+            <a:pPr marL="0" indent="0">
               <a:buNone/>
             </a:pPr>
             <a:r>
@@ -6078,7 +5796,7 @@
           <a:bodyPr wrap="square" lIns="0" tIns="0" rIns="0" bIns="0" rtlCol="0" anchor="ctr"/>
           <a:lstStyle/>
           <a:p>
-            <a:pPr indent="0" marL="0">
+            <a:pPr marL="0" indent="0">
               <a:buNone/>
             </a:pPr>
             <a:r>
@@ -6117,7 +5835,7 @@
           <a:bodyPr wrap="square" lIns="0" tIns="0" rIns="0" bIns="0" rtlCol="0" anchor="ctr"/>
           <a:lstStyle/>
           <a:p>
-            <a:pPr indent="0" marL="0">
+            <a:pPr marL="0" indent="0">
               <a:buNone/>
             </a:pPr>
             <a:r>
@@ -6131,9 +5849,6 @@
               </a:rPr>
               <a:t>SeaWatch</a:t>
             </a:r>
-            <a:pPr indent="0" marL="0">
-              <a:buNone/>
-            </a:pPr>
             <a:r>
               <a:rPr lang="en-US" sz="900" dirty="0">
                 <a:solidFill>
@@ -6170,7 +5885,7 @@
           <a:bodyPr wrap="square" rtlCol="0" anchor="ctr"/>
           <a:lstStyle/>
           <a:p>
-            <a:pPr algn="r" indent="0" marL="0">
+            <a:pPr marL="0" indent="0" algn="r">
               <a:buNone/>
             </a:pPr>
             <a:r>
@@ -6204,6 +5919,7 @@
         <a:solidFill>
           <a:srgbClr val="0A1A2E"/>
         </a:solidFill>
+        <a:effectLst/>
       </p:bgPr>
     </p:bg>
     <p:spTree>
@@ -6241,11 +5957,11 @@
           <a:bodyPr wrap="square" lIns="0" tIns="0" rIns="0" bIns="0" rtlCol="0" anchor="ctr"/>
           <a:lstStyle/>
           <a:p>
-            <a:pPr indent="0" marL="0">
-              <a:buNone/>
-            </a:pPr>
-            <a:r>
-              <a:rPr lang="en-US" sz="1250" b="1" spc="200" kern="0" dirty="0">
+            <a:pPr marL="0" indent="0">
+              <a:buNone/>
+            </a:pPr>
+            <a:r>
+              <a:rPr lang="en-US" sz="1250" b="1" kern="0" spc="200" dirty="0">
                 <a:solidFill>
                   <a:srgbClr val="F2C200"/>
                 </a:solidFill>
@@ -6280,7 +5996,7 @@
           <a:bodyPr wrap="square" lIns="0" tIns="0" rIns="0" bIns="0" rtlCol="0" anchor="t"/>
           <a:lstStyle/>
           <a:p>
-            <a:pPr indent="0" marL="0">
+            <a:pPr marL="0" indent="0">
               <a:buNone/>
             </a:pPr>
             <a:r>
@@ -6319,7 +6035,7 @@
           </a:solidFill>
           <a:ln/>
           <a:effectLst>
-            <a:outerShdw sx="100000" sy="100000" kx="0" ky="0" algn="bl" rotWithShape="0" blurRad="101600" dist="38100" dir="5400000">
+            <a:outerShdw blurRad="101600" dist="38100" dir="5400000" algn="bl" rotWithShape="0">
               <a:srgbClr val="0A1626">
                 <a:alpha val="10000"/>
               </a:srgbClr>
@@ -6348,7 +6064,7 @@
           <a:bodyPr wrap="square" lIns="0" tIns="0" rIns="0" bIns="0" rtlCol="0" anchor="t"/>
           <a:lstStyle/>
           <a:p>
-            <a:pPr indent="0" marL="0">
+            <a:pPr marL="0" indent="0">
               <a:buNone/>
             </a:pPr>
             <a:r>
@@ -6387,7 +6103,7 @@
           <a:bodyPr wrap="square" lIns="0" tIns="0" rIns="0" bIns="0" rtlCol="0" anchor="t"/>
           <a:lstStyle/>
           <a:p>
-            <a:pPr indent="0" marL="0">
+            <a:pPr marL="0" indent="0">
               <a:buNone/>
             </a:pPr>
             <a:r>
@@ -6426,7 +6142,7 @@
           </a:solidFill>
           <a:ln/>
           <a:effectLst>
-            <a:outerShdw sx="100000" sy="100000" kx="0" ky="0" algn="bl" rotWithShape="0" blurRad="101600" dist="38100" dir="5400000">
+            <a:outerShdw blurRad="101600" dist="38100" dir="5400000" algn="bl" rotWithShape="0">
               <a:srgbClr val="0A1626">
                 <a:alpha val="10000"/>
               </a:srgbClr>
@@ -6455,7 +6171,7 @@
           <a:bodyPr wrap="square" lIns="0" tIns="0" rIns="0" bIns="0" rtlCol="0" anchor="t"/>
           <a:lstStyle/>
           <a:p>
-            <a:pPr indent="0" marL="0">
+            <a:pPr marL="0" indent="0">
               <a:buNone/>
             </a:pPr>
             <a:r>
@@ -6494,7 +6210,7 @@
           <a:bodyPr wrap="square" lIns="0" tIns="0" rIns="0" bIns="0" rtlCol="0" anchor="t"/>
           <a:lstStyle/>
           <a:p>
-            <a:pPr indent="0" marL="0">
+            <a:pPr marL="0" indent="0">
               <a:buNone/>
             </a:pPr>
             <a:r>
@@ -6533,7 +6249,7 @@
           </a:solidFill>
           <a:ln/>
           <a:effectLst>
-            <a:outerShdw sx="100000" sy="100000" kx="0" ky="0" algn="bl" rotWithShape="0" blurRad="101600" dist="38100" dir="5400000">
+            <a:outerShdw blurRad="101600" dist="38100" dir="5400000" algn="bl" rotWithShape="0">
               <a:srgbClr val="0A1626">
                 <a:alpha val="10000"/>
               </a:srgbClr>
@@ -6562,7 +6278,7 @@
           <a:bodyPr wrap="square" lIns="0" tIns="0" rIns="0" bIns="0" rtlCol="0" anchor="t"/>
           <a:lstStyle/>
           <a:p>
-            <a:pPr indent="0" marL="0">
+            <a:pPr marL="0" indent="0">
               <a:buNone/>
             </a:pPr>
             <a:r>
@@ -6601,7 +6317,7 @@
           <a:bodyPr wrap="square" lIns="0" tIns="0" rIns="0" bIns="0" rtlCol="0" anchor="t"/>
           <a:lstStyle/>
           <a:p>
-            <a:pPr indent="0" marL="0">
+            <a:pPr marL="0" indent="0">
               <a:buNone/>
             </a:pPr>
             <a:r>
@@ -6640,7 +6356,7 @@
           </a:solidFill>
           <a:ln/>
           <a:effectLst>
-            <a:outerShdw sx="100000" sy="100000" kx="0" ky="0" algn="bl" rotWithShape="0" blurRad="101600" dist="38100" dir="5400000">
+            <a:outerShdw blurRad="101600" dist="38100" dir="5400000" algn="bl" rotWithShape="0">
               <a:srgbClr val="0A1626">
                 <a:alpha val="10000"/>
               </a:srgbClr>
@@ -6669,7 +6385,7 @@
           <a:bodyPr wrap="square" lIns="0" tIns="0" rIns="0" bIns="0" rtlCol="0" anchor="t"/>
           <a:lstStyle/>
           <a:p>
-            <a:pPr indent="0" marL="0">
+            <a:pPr marL="0" indent="0">
               <a:buNone/>
             </a:pPr>
             <a:r>
@@ -6708,7 +6424,7 @@
           <a:bodyPr wrap="square" lIns="0" tIns="0" rIns="0" bIns="0" rtlCol="0" anchor="t"/>
           <a:lstStyle/>
           <a:p>
-            <a:pPr indent="0" marL="0">
+            <a:pPr marL="0" indent="0">
               <a:buNone/>
             </a:pPr>
             <a:r>
@@ -6747,7 +6463,7 @@
           <a:bodyPr wrap="square" lIns="0" tIns="0" rIns="0" bIns="0" rtlCol="0" anchor="ctr"/>
           <a:lstStyle/>
           <a:p>
-            <a:pPr indent="0" marL="0">
+            <a:pPr marL="0" indent="0">
               <a:buNone/>
             </a:pPr>
             <a:r>
@@ -6761,9 +6477,6 @@
               </a:rPr>
               <a:t>SeaWatch</a:t>
             </a:r>
-            <a:pPr indent="0" marL="0">
-              <a:buNone/>
-            </a:pPr>
             <a:r>
               <a:rPr lang="en-US" sz="900" dirty="0">
                 <a:solidFill>
@@ -6800,7 +6513,7 @@
           <a:bodyPr wrap="square" rtlCol="0" anchor="ctr"/>
           <a:lstStyle/>
           <a:p>
-            <a:pPr algn="r" indent="0" marL="0">
+            <a:pPr marL="0" indent="0" algn="r">
               <a:buNone/>
             </a:pPr>
             <a:r>
@@ -6834,6 +6547,7 @@
         <a:solidFill>
           <a:srgbClr val="FFFFFF"/>
         </a:solidFill>
+        <a:effectLst/>
       </p:bgPr>
     </p:bg>
     <p:spTree>
@@ -6871,11 +6585,11 @@
           <a:bodyPr wrap="square" lIns="0" tIns="0" rIns="0" bIns="0" rtlCol="0" anchor="ctr"/>
           <a:lstStyle/>
           <a:p>
-            <a:pPr indent="0" marL="0">
-              <a:buNone/>
-            </a:pPr>
-            <a:r>
-              <a:rPr lang="en-US" sz="1250" b="1" spc="200" kern="0" dirty="0">
+            <a:pPr marL="0" indent="0">
+              <a:buNone/>
+            </a:pPr>
+            <a:r>
+              <a:rPr lang="en-US" sz="1250" b="1" kern="0" spc="200" dirty="0">
                 <a:solidFill>
                   <a:srgbClr val="0B7A3B"/>
                 </a:solidFill>
@@ -6910,7 +6624,7 @@
           <a:bodyPr wrap="square" lIns="0" tIns="0" rIns="0" bIns="0" rtlCol="0" anchor="ctr"/>
           <a:lstStyle/>
           <a:p>
-            <a:pPr indent="0" marL="0">
+            <a:pPr marL="0" indent="0">
               <a:buNone/>
             </a:pPr>
             <a:r>
@@ -6949,7 +6663,7 @@
           </a:solidFill>
           <a:ln/>
           <a:effectLst>
-            <a:outerShdw sx="100000" sy="100000" kx="0" ky="0" algn="bl" rotWithShape="0" blurRad="101600" dist="38100" dir="5400000">
+            <a:outerShdw blurRad="101600" dist="38100" dir="5400000" algn="bl" rotWithShape="0">
               <a:srgbClr val="0A1626">
                 <a:alpha val="10000"/>
               </a:srgbClr>
@@ -7000,7 +6714,7 @@
           <a:bodyPr wrap="square" lIns="0" tIns="0" rIns="0" bIns="0" rtlCol="0" anchor="ctr"/>
           <a:lstStyle/>
           <a:p>
-            <a:pPr algn="ctr" indent="0" marL="0">
+            <a:pPr marL="0" indent="0" algn="ctr">
               <a:buNone/>
             </a:pPr>
             <a:r>
@@ -7039,7 +6753,7 @@
           <a:bodyPr wrap="square" lIns="0" tIns="0" rIns="0" bIns="0" rtlCol="0" anchor="t"/>
           <a:lstStyle/>
           <a:p>
-            <a:pPr indent="0" marL="0">
+            <a:pPr marL="0" indent="0">
               <a:buNone/>
             </a:pPr>
             <a:r>
@@ -7102,7 +6816,7 @@
           </a:solidFill>
           <a:ln/>
           <a:effectLst>
-            <a:outerShdw sx="100000" sy="100000" kx="0" ky="0" algn="bl" rotWithShape="0" blurRad="101600" dist="38100" dir="5400000">
+            <a:outerShdw blurRad="101600" dist="38100" dir="5400000" algn="bl" rotWithShape="0">
               <a:srgbClr val="0A1626">
                 <a:alpha val="10000"/>
               </a:srgbClr>
@@ -7153,7 +6867,7 @@
           <a:bodyPr wrap="square" lIns="0" tIns="0" rIns="0" bIns="0" rtlCol="0" anchor="ctr"/>
           <a:lstStyle/>
           <a:p>
-            <a:pPr algn="ctr" indent="0" marL="0">
+            <a:pPr marL="0" indent="0" algn="ctr">
               <a:buNone/>
             </a:pPr>
             <a:r>
@@ -7192,7 +6906,7 @@
           <a:bodyPr wrap="square" lIns="0" tIns="0" rIns="0" bIns="0" rtlCol="0" anchor="t"/>
           <a:lstStyle/>
           <a:p>
-            <a:pPr indent="0" marL="0">
+            <a:pPr marL="0" indent="0">
               <a:buNone/>
             </a:pPr>
             <a:r>
@@ -7255,7 +6969,7 @@
           </a:solidFill>
           <a:ln/>
           <a:effectLst>
-            <a:outerShdw sx="100000" sy="100000" kx="0" ky="0" algn="bl" rotWithShape="0" blurRad="101600" dist="38100" dir="5400000">
+            <a:outerShdw blurRad="101600" dist="38100" dir="5400000" algn="bl" rotWithShape="0">
               <a:srgbClr val="0A1626">
                 <a:alpha val="10000"/>
               </a:srgbClr>
@@ -7306,7 +7020,7 @@
           <a:bodyPr wrap="square" lIns="0" tIns="0" rIns="0" bIns="0" rtlCol="0" anchor="ctr"/>
           <a:lstStyle/>
           <a:p>
-            <a:pPr algn="ctr" indent="0" marL="0">
+            <a:pPr marL="0" indent="0" algn="ctr">
               <a:buNone/>
             </a:pPr>
             <a:r>
@@ -7345,7 +7059,7 @@
           <a:bodyPr wrap="square" lIns="0" tIns="0" rIns="0" bIns="0" rtlCol="0" anchor="t"/>
           <a:lstStyle/>
           <a:p>
-            <a:pPr indent="0" marL="0">
+            <a:pPr marL="0" indent="0">
               <a:buNone/>
             </a:pPr>
             <a:r>
@@ -7408,7 +7122,7 @@
           </a:solidFill>
           <a:ln/>
           <a:effectLst>
-            <a:outerShdw sx="100000" sy="100000" kx="0" ky="0" algn="bl" rotWithShape="0" blurRad="101600" dist="38100" dir="5400000">
+            <a:outerShdw blurRad="101600" dist="38100" dir="5400000" algn="bl" rotWithShape="0">
               <a:srgbClr val="0A1626">
                 <a:alpha val="10000"/>
               </a:srgbClr>
@@ -7459,7 +7173,7 @@
           <a:bodyPr wrap="square" lIns="0" tIns="0" rIns="0" bIns="0" rtlCol="0" anchor="ctr"/>
           <a:lstStyle/>
           <a:p>
-            <a:pPr algn="ctr" indent="0" marL="0">
+            <a:pPr marL="0" indent="0" algn="ctr">
               <a:buNone/>
             </a:pPr>
             <a:r>
@@ -7498,7 +7212,7 @@
           <a:bodyPr wrap="square" lIns="0" tIns="0" rIns="0" bIns="0" rtlCol="0" anchor="t"/>
           <a:lstStyle/>
           <a:p>
-            <a:pPr indent="0" marL="0">
+            <a:pPr marL="0" indent="0">
               <a:buNone/>
             </a:pPr>
             <a:r>
@@ -7537,7 +7251,7 @@
           <a:bodyPr wrap="square" lIns="0" tIns="0" rIns="0" bIns="0" rtlCol="0" anchor="ctr"/>
           <a:lstStyle/>
           <a:p>
-            <a:pPr indent="0" marL="0">
+            <a:pPr marL="0" indent="0">
               <a:buNone/>
             </a:pPr>
             <a:r>
@@ -7551,9 +7265,6 @@
               </a:rPr>
               <a:t>SeaWatch</a:t>
             </a:r>
-            <a:pPr indent="0" marL="0">
-              <a:buNone/>
-            </a:pPr>
             <a:r>
               <a:rPr lang="en-US" sz="900" dirty="0">
                 <a:solidFill>
@@ -7590,7 +7301,7 @@
           <a:bodyPr wrap="square" rtlCol="0" anchor="ctr"/>
           <a:lstStyle/>
           <a:p>
-            <a:pPr algn="r" indent="0" marL="0">
+            <a:pPr marL="0" indent="0" algn="r">
               <a:buNone/>
             </a:pPr>
             <a:r>
@@ -7624,6 +7335,7 @@
         <a:solidFill>
           <a:srgbClr val="0A1A2E"/>
         </a:solidFill>
+        <a:effectLst/>
       </p:bgPr>
     </p:bg>
     <p:spTree>
@@ -7642,14 +7354,14 @@
       </p:grpSpPr>
       <p:pic>
         <p:nvPicPr>
-          <p:cNvPr id="2" name="Image 0" descr="crest.png">    </p:cNvPr>
+          <p:cNvPr id="2" name="Image 0" descr="crest.png"/>
           <p:cNvPicPr>
             <a:picLocks noChangeAspect="1"/>
           </p:cNvPicPr>
           <p:nvPr/>
         </p:nvPicPr>
         <p:blipFill>
-          <a:blip r:embed="rId1"/>
+          <a:blip r:embed="rId3"/>
           <a:stretch>
             <a:fillRect/>
           </a:stretch>
@@ -7685,7 +7397,7 @@
           <a:bodyPr wrap="square" lIns="0" tIns="0" rIns="0" bIns="0" rtlCol="0" anchor="ctr"/>
           <a:lstStyle/>
           <a:p>
-            <a:pPr algn="ctr" indent="0" marL="0">
+            <a:pPr marL="0" indent="0" algn="ctr">
               <a:buNone/>
             </a:pPr>
             <a:r>
@@ -7724,7 +7436,7 @@
           <a:bodyPr wrap="square" lIns="0" tIns="0" rIns="0" bIns="0" rtlCol="0" anchor="ctr"/>
           <a:lstStyle/>
           <a:p>
-            <a:pPr algn="ctr" indent="0" marL="0">
+            <a:pPr marL="0" indent="0" algn="ctr">
               <a:buNone/>
             </a:pPr>
             <a:r>
@@ -7786,7 +7498,7 @@
           <a:bodyPr wrap="square" lIns="0" tIns="0" rIns="0" bIns="0" rtlCol="0" anchor="ctr"/>
           <a:lstStyle/>
           <a:p>
-            <a:pPr algn="ctr" indent="0" marL="0">
+            <a:pPr marL="0" indent="0" algn="ctr">
               <a:buNone/>
             </a:pPr>
             <a:r>
@@ -7825,7 +7537,7 @@
           <a:bodyPr wrap="square" lIns="0" tIns="0" rIns="0" bIns="0" rtlCol="0" anchor="ctr"/>
           <a:lstStyle/>
           <a:p>
-            <a:pPr algn="ctr" indent="0" marL="0">
+            <a:pPr marL="0" indent="0" algn="ctr">
               <a:buNone/>
             </a:pPr>
             <a:r>
@@ -7859,6 +7571,7 @@
         <a:solidFill>
           <a:srgbClr val="FFFFFF"/>
         </a:solidFill>
+        <a:effectLst/>
       </p:bgPr>
     </p:bg>
     <p:spTree>
@@ -7896,11 +7609,11 @@
           <a:bodyPr wrap="square" lIns="0" tIns="0" rIns="0" bIns="0" rtlCol="0" anchor="ctr"/>
           <a:lstStyle/>
           <a:p>
-            <a:pPr indent="0" marL="0">
-              <a:buNone/>
-            </a:pPr>
-            <a:r>
-              <a:rPr lang="en-US" sz="1250" b="1" spc="200" kern="0" dirty="0">
+            <a:pPr marL="0" indent="0">
+              <a:buNone/>
+            </a:pPr>
+            <a:r>
+              <a:rPr lang="en-US" sz="1250" b="1" kern="0" spc="200" dirty="0">
                 <a:solidFill>
                   <a:srgbClr val="C8102E"/>
                 </a:solidFill>
@@ -7935,7 +7648,7 @@
           <a:bodyPr wrap="square" lIns="0" tIns="0" rIns="0" bIns="0" rtlCol="0" anchor="ctr"/>
           <a:lstStyle/>
           <a:p>
-            <a:pPr indent="0" marL="0">
+            <a:pPr marL="0" indent="0">
               <a:buNone/>
             </a:pPr>
             <a:r>
@@ -7974,7 +7687,7 @@
           </a:solidFill>
           <a:ln/>
           <a:effectLst>
-            <a:outerShdw sx="100000" sy="100000" kx="0" ky="0" algn="bl" rotWithShape="0" blurRad="101600" dist="38100" dir="5400000">
+            <a:outerShdw blurRad="101600" dist="38100" dir="5400000" algn="bl" rotWithShape="0">
               <a:srgbClr val="0A1626">
                 <a:alpha val="10000"/>
               </a:srgbClr>
@@ -8003,7 +7716,7 @@
           <a:bodyPr wrap="square" lIns="0" tIns="0" rIns="0" bIns="0" rtlCol="0" anchor="ctr"/>
           <a:lstStyle/>
           <a:p>
-            <a:pPr algn="ctr" indent="0" marL="0">
+            <a:pPr marL="0" indent="0" algn="ctr">
               <a:buNone/>
             </a:pPr>
             <a:r>
@@ -8042,7 +7755,7 @@
           <a:bodyPr wrap="square" lIns="0" tIns="0" rIns="0" bIns="0" rtlCol="0" anchor="ctr"/>
           <a:lstStyle/>
           <a:p>
-            <a:pPr algn="ctr" indent="0" marL="0">
+            <a:pPr marL="0" indent="0" algn="ctr">
               <a:buNone/>
             </a:pPr>
             <a:r>
@@ -8059,7 +7772,7 @@
             <a:endParaRPr lang="en-US" sz="1100" dirty="0"/>
           </a:p>
           <a:p>
-            <a:pPr algn="ctr" indent="0" marL="0">
+            <a:pPr marL="0" indent="0" algn="ctr">
               <a:buNone/>
             </a:pPr>
             <a:r>
@@ -8098,7 +7811,7 @@
           </a:solidFill>
           <a:ln/>
           <a:effectLst>
-            <a:outerShdw sx="100000" sy="100000" kx="0" ky="0" algn="bl" rotWithShape="0" blurRad="101600" dist="38100" dir="5400000">
+            <a:outerShdw blurRad="101600" dist="38100" dir="5400000" algn="bl" rotWithShape="0">
               <a:srgbClr val="0A1626">
                 <a:alpha val="10000"/>
               </a:srgbClr>
@@ -8127,7 +7840,7 @@
           <a:bodyPr wrap="square" lIns="0" tIns="0" rIns="0" bIns="0" rtlCol="0" anchor="ctr"/>
           <a:lstStyle/>
           <a:p>
-            <a:pPr algn="ctr" indent="0" marL="0">
+            <a:pPr marL="0" indent="0" algn="ctr">
               <a:buNone/>
             </a:pPr>
             <a:r>
@@ -8166,7 +7879,7 @@
           <a:bodyPr wrap="square" lIns="0" tIns="0" rIns="0" bIns="0" rtlCol="0" anchor="ctr"/>
           <a:lstStyle/>
           <a:p>
-            <a:pPr algn="ctr" indent="0" marL="0">
+            <a:pPr marL="0" indent="0" algn="ctr">
               <a:buNone/>
             </a:pPr>
             <a:r>
@@ -8183,7 +7896,7 @@
             <a:endParaRPr lang="en-US" sz="1100" dirty="0"/>
           </a:p>
           <a:p>
-            <a:pPr algn="ctr" indent="0" marL="0">
+            <a:pPr marL="0" indent="0" algn="ctr">
               <a:buNone/>
             </a:pPr>
             <a:r>
@@ -8222,7 +7935,7 @@
           </a:solidFill>
           <a:ln/>
           <a:effectLst>
-            <a:outerShdw sx="100000" sy="100000" kx="0" ky="0" algn="bl" rotWithShape="0" blurRad="101600" dist="38100" dir="5400000">
+            <a:outerShdw blurRad="101600" dist="38100" dir="5400000" algn="bl" rotWithShape="0">
               <a:srgbClr val="0A1626">
                 <a:alpha val="10000"/>
               </a:srgbClr>
@@ -8251,7 +7964,7 @@
           <a:bodyPr wrap="square" lIns="0" tIns="0" rIns="0" bIns="0" rtlCol="0" anchor="ctr"/>
           <a:lstStyle/>
           <a:p>
-            <a:pPr algn="ctr" indent="0" marL="0">
+            <a:pPr marL="0" indent="0" algn="ctr">
               <a:buNone/>
             </a:pPr>
             <a:r>
@@ -8290,7 +8003,7 @@
           <a:bodyPr wrap="square" lIns="0" tIns="0" rIns="0" bIns="0" rtlCol="0" anchor="ctr"/>
           <a:lstStyle/>
           <a:p>
-            <a:pPr algn="ctr" indent="0" marL="0">
+            <a:pPr marL="0" indent="0" algn="ctr">
               <a:buNone/>
             </a:pPr>
             <a:r>
@@ -8307,7 +8020,7 @@
             <a:endParaRPr lang="en-US" sz="1100" dirty="0"/>
           </a:p>
           <a:p>
-            <a:pPr algn="ctr" indent="0" marL="0">
+            <a:pPr marL="0" indent="0" algn="ctr">
               <a:buNone/>
             </a:pPr>
             <a:r>
@@ -8346,7 +8059,7 @@
           </a:solidFill>
           <a:ln/>
           <a:effectLst>
-            <a:outerShdw sx="100000" sy="100000" kx="0" ky="0" algn="bl" rotWithShape="0" blurRad="101600" dist="38100" dir="5400000">
+            <a:outerShdw blurRad="101600" dist="38100" dir="5400000" algn="bl" rotWithShape="0">
               <a:srgbClr val="0A1626">
                 <a:alpha val="10000"/>
               </a:srgbClr>
@@ -8375,11 +8088,11 @@
           <a:bodyPr wrap="square" lIns="0" tIns="0" rIns="0" bIns="0" rtlCol="0" anchor="ctr"/>
           <a:lstStyle/>
           <a:p>
-            <a:pPr indent="0" marL="0">
-              <a:buNone/>
-            </a:pPr>
-            <a:r>
-              <a:rPr lang="en-US" sz="1250" b="1" spc="150" kern="0" dirty="0">
+            <a:pPr marL="0" indent="0">
+              <a:buNone/>
+            </a:pPr>
+            <a:r>
+              <a:rPr lang="en-US" sz="1250" b="1" kern="0" spc="150" dirty="0">
                 <a:solidFill>
                   <a:srgbClr val="F2C200"/>
                 </a:solidFill>
@@ -8434,7 +8147,7 @@
           <a:bodyPr wrap="square" lIns="0" tIns="0" rIns="0" bIns="0" rtlCol="0" anchor="ctr"/>
           <a:lstStyle/>
           <a:p>
-            <a:pPr indent="0" marL="0">
+            <a:pPr marL="0" indent="0">
               <a:buNone/>
             </a:pPr>
             <a:r>
@@ -8473,7 +8186,7 @@
           <a:bodyPr wrap="square" lIns="0" tIns="0" rIns="0" bIns="0" rtlCol="0" anchor="ctr"/>
           <a:lstStyle/>
           <a:p>
-            <a:pPr indent="0" marL="0">
+            <a:pPr marL="0" indent="0">
               <a:buNone/>
             </a:pPr>
             <a:r>
@@ -8532,7 +8245,7 @@
           <a:bodyPr wrap="square" lIns="0" tIns="0" rIns="0" bIns="0" rtlCol="0" anchor="ctr"/>
           <a:lstStyle/>
           <a:p>
-            <a:pPr indent="0" marL="0">
+            <a:pPr marL="0" indent="0">
               <a:buNone/>
             </a:pPr>
             <a:r>
@@ -8571,7 +8284,7 @@
           <a:bodyPr wrap="square" lIns="0" tIns="0" rIns="0" bIns="0" rtlCol="0" anchor="ctr"/>
           <a:lstStyle/>
           <a:p>
-            <a:pPr indent="0" marL="0">
+            <a:pPr marL="0" indent="0">
               <a:buNone/>
             </a:pPr>
             <a:r>
@@ -8630,7 +8343,7 @@
           <a:bodyPr wrap="square" lIns="0" tIns="0" rIns="0" bIns="0" rtlCol="0" anchor="ctr"/>
           <a:lstStyle/>
           <a:p>
-            <a:pPr indent="0" marL="0">
+            <a:pPr marL="0" indent="0">
               <a:buNone/>
             </a:pPr>
             <a:r>
@@ -8669,7 +8382,7 @@
           <a:bodyPr wrap="square" lIns="0" tIns="0" rIns="0" bIns="0" rtlCol="0" anchor="ctr"/>
           <a:lstStyle/>
           <a:p>
-            <a:pPr indent="0" marL="0">
+            <a:pPr marL="0" indent="0">
               <a:buNone/>
             </a:pPr>
             <a:r>
@@ -8728,7 +8441,7 @@
           <a:bodyPr wrap="square" lIns="0" tIns="0" rIns="0" bIns="0" rtlCol="0" anchor="ctr"/>
           <a:lstStyle/>
           <a:p>
-            <a:pPr indent="0" marL="0">
+            <a:pPr marL="0" indent="0">
               <a:buNone/>
             </a:pPr>
             <a:r>
@@ -8767,7 +8480,7 @@
           <a:bodyPr wrap="square" lIns="0" tIns="0" rIns="0" bIns="0" rtlCol="0" anchor="ctr"/>
           <a:lstStyle/>
           <a:p>
-            <a:pPr indent="0" marL="0">
+            <a:pPr marL="0" indent="0">
               <a:buNone/>
             </a:pPr>
             <a:r>
@@ -8826,7 +8539,7 @@
           <a:bodyPr wrap="square" lIns="0" tIns="0" rIns="0" bIns="0" rtlCol="0" anchor="ctr"/>
           <a:lstStyle/>
           <a:p>
-            <a:pPr indent="0" marL="0">
+            <a:pPr marL="0" indent="0">
               <a:buNone/>
             </a:pPr>
             <a:r>
@@ -8865,7 +8578,7 @@
           <a:bodyPr wrap="square" lIns="0" tIns="0" rIns="0" bIns="0" rtlCol="0" anchor="ctr"/>
           <a:lstStyle/>
           <a:p>
-            <a:pPr indent="0" marL="0">
+            <a:pPr marL="0" indent="0">
               <a:buNone/>
             </a:pPr>
             <a:r>
@@ -8904,7 +8617,7 @@
           <a:bodyPr wrap="square" lIns="0" tIns="0" rIns="0" bIns="0" rtlCol="0" anchor="t"/>
           <a:lstStyle/>
           <a:p>
-            <a:pPr indent="0" marL="0">
+            <a:pPr marL="0" indent="0">
               <a:buNone/>
             </a:pPr>
             <a:r>
@@ -8943,7 +8656,7 @@
           <a:bodyPr wrap="square" lIns="0" tIns="0" rIns="0" bIns="0" rtlCol="0" anchor="ctr"/>
           <a:lstStyle/>
           <a:p>
-            <a:pPr indent="0" marL="0">
+            <a:pPr marL="0" indent="0">
               <a:buNone/>
             </a:pPr>
             <a:r>
@@ -8957,9 +8670,6 @@
               </a:rPr>
               <a:t>SeaWatch</a:t>
             </a:r>
-            <a:pPr indent="0" marL="0">
-              <a:buNone/>
-            </a:pPr>
             <a:r>
               <a:rPr lang="en-US" sz="900" dirty="0">
                 <a:solidFill>
@@ -8996,7 +8706,7 @@
           <a:bodyPr wrap="square" rtlCol="0" anchor="ctr"/>
           <a:lstStyle/>
           <a:p>
-            <a:pPr algn="r" indent="0" marL="0">
+            <a:pPr marL="0" indent="0" algn="r">
               <a:buNone/>
             </a:pPr>
             <a:r>
@@ -9030,6 +8740,7 @@
         <a:solidFill>
           <a:srgbClr val="FFFFFF"/>
         </a:solidFill>
+        <a:effectLst/>
       </p:bgPr>
     </p:bg>
     <p:spTree>
@@ -9067,11 +8778,11 @@
           <a:bodyPr wrap="square" lIns="0" tIns="0" rIns="0" bIns="0" rtlCol="0" anchor="ctr"/>
           <a:lstStyle/>
           <a:p>
-            <a:pPr indent="0" marL="0">
-              <a:buNone/>
-            </a:pPr>
-            <a:r>
-              <a:rPr lang="en-US" sz="1250" b="1" spc="200" kern="0" dirty="0">
+            <a:pPr marL="0" indent="0">
+              <a:buNone/>
+            </a:pPr>
+            <a:r>
+              <a:rPr lang="en-US" sz="1250" b="1" kern="0" spc="200" dirty="0">
                 <a:solidFill>
                   <a:srgbClr val="0B7A3B"/>
                 </a:solidFill>
@@ -9106,7 +8817,7 @@
           <a:bodyPr wrap="square" lIns="0" tIns="0" rIns="0" bIns="0" rtlCol="0" anchor="ctr"/>
           <a:lstStyle/>
           <a:p>
-            <a:pPr indent="0" marL="0">
+            <a:pPr marL="0" indent="0">
               <a:buNone/>
             </a:pPr>
             <a:r>
@@ -9145,7 +8856,7 @@
           <a:bodyPr wrap="square" lIns="0" tIns="0" rIns="0" bIns="0" rtlCol="0" anchor="ctr"/>
           <a:lstStyle/>
           <a:p>
-            <a:pPr indent="0" marL="0">
+            <a:pPr marL="0" indent="0">
               <a:buNone/>
             </a:pPr>
             <a:r>
@@ -9184,7 +8895,7 @@
           </a:solidFill>
           <a:ln/>
           <a:effectLst>
-            <a:outerShdw sx="100000" sy="100000" kx="0" ky="0" algn="bl" rotWithShape="0" blurRad="101600" dist="38100" dir="5400000">
+            <a:outerShdw blurRad="101600" dist="38100" dir="5400000" algn="bl" rotWithShape="0">
               <a:srgbClr val="0A1626">
                 <a:alpha val="10000"/>
               </a:srgbClr>
@@ -9233,7 +8944,7 @@
           <a:bodyPr wrap="square" lIns="0" tIns="0" rIns="0" bIns="0" rtlCol="0" anchor="ctr"/>
           <a:lstStyle/>
           <a:p>
-            <a:pPr algn="ctr" indent="0" marL="0">
+            <a:pPr marL="0" indent="0" algn="ctr">
               <a:buNone/>
             </a:pPr>
             <a:r>
@@ -9272,7 +8983,7 @@
           <a:bodyPr wrap="square" lIns="0" tIns="0" rIns="0" bIns="0" rtlCol="0" anchor="ctr"/>
           <a:lstStyle/>
           <a:p>
-            <a:pPr indent="0" marL="0">
+            <a:pPr marL="0" indent="0">
               <a:buNone/>
             </a:pPr>
             <a:r>
@@ -9311,7 +9022,7 @@
           <a:bodyPr wrap="square" lIns="0" tIns="0" rIns="0" bIns="0" rtlCol="0" anchor="t"/>
           <a:lstStyle/>
           <a:p>
-            <a:pPr indent="0" marL="0">
+            <a:pPr marL="0" indent="0">
               <a:buNone/>
             </a:pPr>
             <a:r>
@@ -9350,7 +9061,7 @@
           </a:solidFill>
           <a:ln/>
           <a:effectLst>
-            <a:outerShdw sx="100000" sy="100000" kx="0" ky="0" algn="bl" rotWithShape="0" blurRad="101600" dist="38100" dir="5400000">
+            <a:outerShdw blurRad="101600" dist="38100" dir="5400000" algn="bl" rotWithShape="0">
               <a:srgbClr val="0A1626">
                 <a:alpha val="10000"/>
               </a:srgbClr>
@@ -9399,7 +9110,7 @@
           <a:bodyPr wrap="square" lIns="0" tIns="0" rIns="0" bIns="0" rtlCol="0" anchor="ctr"/>
           <a:lstStyle/>
           <a:p>
-            <a:pPr algn="ctr" indent="0" marL="0">
+            <a:pPr marL="0" indent="0" algn="ctr">
               <a:buNone/>
             </a:pPr>
             <a:r>
@@ -9438,7 +9149,7 @@
           <a:bodyPr wrap="square" lIns="0" tIns="0" rIns="0" bIns="0" rtlCol="0" anchor="ctr"/>
           <a:lstStyle/>
           <a:p>
-            <a:pPr indent="0" marL="0">
+            <a:pPr marL="0" indent="0">
               <a:buNone/>
             </a:pPr>
             <a:r>
@@ -9477,7 +9188,7 @@
           <a:bodyPr wrap="square" lIns="0" tIns="0" rIns="0" bIns="0" rtlCol="0" anchor="t"/>
           <a:lstStyle/>
           <a:p>
-            <a:pPr indent="0" marL="0">
+            <a:pPr marL="0" indent="0">
               <a:buNone/>
             </a:pPr>
             <a:r>
@@ -9516,7 +9227,7 @@
           </a:solidFill>
           <a:ln/>
           <a:effectLst>
-            <a:outerShdw sx="100000" sy="100000" kx="0" ky="0" algn="bl" rotWithShape="0" blurRad="101600" dist="38100" dir="5400000">
+            <a:outerShdw blurRad="101600" dist="38100" dir="5400000" algn="bl" rotWithShape="0">
               <a:srgbClr val="0A1626">
                 <a:alpha val="10000"/>
               </a:srgbClr>
@@ -9565,7 +9276,7 @@
           <a:bodyPr wrap="square" lIns="0" tIns="0" rIns="0" bIns="0" rtlCol="0" anchor="ctr"/>
           <a:lstStyle/>
           <a:p>
-            <a:pPr algn="ctr" indent="0" marL="0">
+            <a:pPr marL="0" indent="0" algn="ctr">
               <a:buNone/>
             </a:pPr>
             <a:r>
@@ -9604,7 +9315,7 @@
           <a:bodyPr wrap="square" lIns="0" tIns="0" rIns="0" bIns="0" rtlCol="0" anchor="ctr"/>
           <a:lstStyle/>
           <a:p>
-            <a:pPr indent="0" marL="0">
+            <a:pPr marL="0" indent="0">
               <a:buNone/>
             </a:pPr>
             <a:r>
@@ -9643,7 +9354,7 @@
           <a:bodyPr wrap="square" lIns="0" tIns="0" rIns="0" bIns="0" rtlCol="0" anchor="t"/>
           <a:lstStyle/>
           <a:p>
-            <a:pPr indent="0" marL="0">
+            <a:pPr marL="0" indent="0">
               <a:buNone/>
             </a:pPr>
             <a:r>
@@ -9682,7 +9393,7 @@
           </a:solidFill>
           <a:ln/>
           <a:effectLst>
-            <a:outerShdw sx="100000" sy="100000" kx="0" ky="0" algn="bl" rotWithShape="0" blurRad="101600" dist="38100" dir="5400000">
+            <a:outerShdw blurRad="101600" dist="38100" dir="5400000" algn="bl" rotWithShape="0">
               <a:srgbClr val="0A1626">
                 <a:alpha val="10000"/>
               </a:srgbClr>
@@ -9731,7 +9442,7 @@
           <a:bodyPr wrap="square" lIns="0" tIns="0" rIns="0" bIns="0" rtlCol="0" anchor="ctr"/>
           <a:lstStyle/>
           <a:p>
-            <a:pPr algn="ctr" indent="0" marL="0">
+            <a:pPr marL="0" indent="0" algn="ctr">
               <a:buNone/>
             </a:pPr>
             <a:r>
@@ -9770,7 +9481,7 @@
           <a:bodyPr wrap="square" lIns="0" tIns="0" rIns="0" bIns="0" rtlCol="0" anchor="ctr"/>
           <a:lstStyle/>
           <a:p>
-            <a:pPr indent="0" marL="0">
+            <a:pPr marL="0" indent="0">
               <a:buNone/>
             </a:pPr>
             <a:r>
@@ -9809,7 +9520,7 @@
           <a:bodyPr wrap="square" lIns="0" tIns="0" rIns="0" bIns="0" rtlCol="0" anchor="t"/>
           <a:lstStyle/>
           <a:p>
-            <a:pPr indent="0" marL="0">
+            <a:pPr marL="0" indent="0">
               <a:buNone/>
             </a:pPr>
             <a:r>
@@ -9848,7 +9559,7 @@
           <a:bodyPr wrap="square" lIns="0" tIns="0" rIns="0" bIns="0" rtlCol="0" anchor="ctr"/>
           <a:lstStyle/>
           <a:p>
-            <a:pPr indent="0" marL="0">
+            <a:pPr marL="0" indent="0">
               <a:buNone/>
             </a:pPr>
             <a:r>
@@ -9862,9 +9573,6 @@
               </a:rPr>
               <a:t>SeaWatch</a:t>
             </a:r>
-            <a:pPr indent="0" marL="0">
-              <a:buNone/>
-            </a:pPr>
             <a:r>
               <a:rPr lang="en-US" sz="900" dirty="0">
                 <a:solidFill>
@@ -9901,7 +9609,7 @@
           <a:bodyPr wrap="square" rtlCol="0" anchor="ctr"/>
           <a:lstStyle/>
           <a:p>
-            <a:pPr algn="r" indent="0" marL="0">
+            <a:pPr marL="0" indent="0" algn="r">
               <a:buNone/>
             </a:pPr>
             <a:r>
@@ -9935,6 +9643,7 @@
         <a:solidFill>
           <a:srgbClr val="FFFFFF"/>
         </a:solidFill>
+        <a:effectLst/>
       </p:bgPr>
     </p:bg>
     <p:spTree>
@@ -9972,11 +9681,11 @@
           <a:bodyPr wrap="square" lIns="0" tIns="0" rIns="0" bIns="0" rtlCol="0" anchor="ctr"/>
           <a:lstStyle/>
           <a:p>
-            <a:pPr indent="0" marL="0">
-              <a:buNone/>
-            </a:pPr>
-            <a:r>
-              <a:rPr lang="en-US" sz="1250" b="1" spc="200" kern="0" dirty="0">
+            <a:pPr marL="0" indent="0">
+              <a:buNone/>
+            </a:pPr>
+            <a:r>
+              <a:rPr lang="en-US" sz="1250" b="1" kern="0" spc="200" dirty="0">
                 <a:solidFill>
                   <a:srgbClr val="2E6FB0"/>
                 </a:solidFill>
@@ -10011,7 +9720,7 @@
           <a:bodyPr wrap="square" lIns="0" tIns="0" rIns="0" bIns="0" rtlCol="0" anchor="ctr"/>
           <a:lstStyle/>
           <a:p>
-            <a:pPr indent="0" marL="0">
+            <a:pPr marL="0" indent="0">
               <a:buNone/>
             </a:pPr>
             <a:r>
@@ -10050,7 +9759,7 @@
           </a:solidFill>
           <a:ln/>
           <a:effectLst>
-            <a:outerShdw sx="100000" sy="100000" kx="0" ky="0" algn="bl" rotWithShape="0" blurRad="101600" dist="38100" dir="5400000">
+            <a:outerShdw blurRad="101600" dist="38100" dir="5400000" algn="bl" rotWithShape="0">
               <a:srgbClr val="0A1626">
                 <a:alpha val="10000"/>
               </a:srgbClr>
@@ -10079,7 +9788,7 @@
           <a:bodyPr wrap="square" lIns="0" tIns="0" rIns="0" bIns="0" rtlCol="0" anchor="ctr"/>
           <a:lstStyle/>
           <a:p>
-            <a:pPr indent="0" marL="0">
+            <a:pPr marL="0" indent="0">
               <a:buNone/>
             </a:pPr>
             <a:r>
@@ -10118,7 +9827,7 @@
           <a:bodyPr wrap="square" lIns="0" tIns="0" rIns="0" bIns="0" rtlCol="0" anchor="ctr"/>
           <a:lstStyle/>
           <a:p>
-            <a:pPr indent="0" marL="0">
+            <a:pPr marL="0" indent="0">
               <a:buNone/>
             </a:pPr>
             <a:r>
@@ -10135,7 +9844,7 @@
             <a:endParaRPr lang="en-US" sz="1050" dirty="0"/>
           </a:p>
           <a:p>
-            <a:pPr indent="0" marL="0">
+            <a:pPr marL="0" indent="0">
               <a:buNone/>
             </a:pPr>
             <a:r>
@@ -10174,7 +9883,7 @@
           </a:solidFill>
           <a:ln/>
           <a:effectLst>
-            <a:outerShdw sx="100000" sy="100000" kx="0" ky="0" algn="bl" rotWithShape="0" blurRad="101600" dist="38100" dir="5400000">
+            <a:outerShdw blurRad="101600" dist="38100" dir="5400000" algn="bl" rotWithShape="0">
               <a:srgbClr val="0A1626">
                 <a:alpha val="10000"/>
               </a:srgbClr>
@@ -10203,7 +9912,7 @@
           <a:bodyPr wrap="square" lIns="0" tIns="0" rIns="0" bIns="0" rtlCol="0" anchor="ctr"/>
           <a:lstStyle/>
           <a:p>
-            <a:pPr indent="0" marL="0">
+            <a:pPr marL="0" indent="0">
               <a:buNone/>
             </a:pPr>
             <a:r>
@@ -10242,7 +9951,7 @@
           <a:bodyPr wrap="square" lIns="0" tIns="0" rIns="0" bIns="0" rtlCol="0" anchor="ctr"/>
           <a:lstStyle/>
           <a:p>
-            <a:pPr indent="0" marL="0">
+            <a:pPr marL="0" indent="0">
               <a:buNone/>
             </a:pPr>
             <a:r>
@@ -10259,7 +9968,7 @@
             <a:endParaRPr lang="en-US" sz="1050" dirty="0"/>
           </a:p>
           <a:p>
-            <a:pPr indent="0" marL="0">
+            <a:pPr marL="0" indent="0">
               <a:buNone/>
             </a:pPr>
             <a:r>
@@ -10298,7 +10007,7 @@
           </a:solidFill>
           <a:ln/>
           <a:effectLst>
-            <a:outerShdw sx="100000" sy="100000" kx="0" ky="0" algn="bl" rotWithShape="0" blurRad="101600" dist="38100" dir="5400000">
+            <a:outerShdw blurRad="101600" dist="38100" dir="5400000" algn="bl" rotWithShape="0">
               <a:srgbClr val="0A1626">
                 <a:alpha val="10000"/>
               </a:srgbClr>
@@ -10327,7 +10036,7 @@
           <a:bodyPr wrap="square" lIns="0" tIns="0" rIns="0" bIns="0" rtlCol="0" anchor="ctr"/>
           <a:lstStyle/>
           <a:p>
-            <a:pPr indent="0" marL="0">
+            <a:pPr marL="0" indent="0">
               <a:buNone/>
             </a:pPr>
             <a:r>
@@ -10366,7 +10075,7 @@
           <a:bodyPr wrap="square" lIns="0" tIns="0" rIns="0" bIns="0" rtlCol="0" anchor="ctr"/>
           <a:lstStyle/>
           <a:p>
-            <a:pPr indent="0" marL="0">
+            <a:pPr marL="0" indent="0">
               <a:buNone/>
             </a:pPr>
             <a:r>
@@ -10383,7 +10092,7 @@
             <a:endParaRPr lang="en-US" sz="1050" dirty="0"/>
           </a:p>
           <a:p>
-            <a:pPr indent="0" marL="0">
+            <a:pPr marL="0" indent="0">
               <a:buNone/>
             </a:pPr>
             <a:r>
@@ -10422,7 +10131,7 @@
           </a:solidFill>
           <a:ln/>
           <a:effectLst>
-            <a:outerShdw sx="100000" sy="100000" kx="0" ky="0" algn="bl" rotWithShape="0" blurRad="101600" dist="38100" dir="5400000">
+            <a:outerShdw blurRad="101600" dist="38100" dir="5400000" algn="bl" rotWithShape="0">
               <a:srgbClr val="0A1626">
                 <a:alpha val="10000"/>
               </a:srgbClr>
@@ -10451,7 +10160,7 @@
           <a:bodyPr wrap="square" lIns="0" tIns="0" rIns="0" bIns="0" rtlCol="0" anchor="ctr"/>
           <a:lstStyle/>
           <a:p>
-            <a:pPr algn="ctr" indent="0" marL="0">
+            <a:pPr marL="0" indent="0" algn="ctr">
               <a:buNone/>
             </a:pPr>
             <a:r>
@@ -10490,7 +10199,7 @@
           <a:bodyPr wrap="square" lIns="0" tIns="0" rIns="0" bIns="0" rtlCol="0" anchor="ctr"/>
           <a:lstStyle/>
           <a:p>
-            <a:pPr algn="ctr" indent="0" marL="0">
+            <a:pPr marL="0" indent="0" algn="ctr">
               <a:buNone/>
             </a:pPr>
             <a:r>
@@ -10507,7 +10216,7 @@
             <a:endParaRPr lang="en-US" sz="1200" dirty="0"/>
           </a:p>
           <a:p>
-            <a:pPr algn="ctr" indent="0" marL="0">
+            <a:pPr marL="0" indent="0" algn="ctr">
               <a:buNone/>
             </a:pPr>
             <a:r>
@@ -10642,7 +10351,7 @@
           </a:solidFill>
           <a:ln/>
           <a:effectLst>
-            <a:outerShdw sx="100000" sy="100000" kx="0" ky="0" algn="bl" rotWithShape="0" blurRad="101600" dist="38100" dir="5400000">
+            <a:outerShdw blurRad="101600" dist="38100" dir="5400000" algn="bl" rotWithShape="0">
               <a:srgbClr val="0A1626">
                 <a:alpha val="10000"/>
               </a:srgbClr>
@@ -10671,11 +10380,11 @@
           <a:bodyPr wrap="square" lIns="0" tIns="0" rIns="0" bIns="0" rtlCol="0" anchor="ctr"/>
           <a:lstStyle/>
           <a:p>
-            <a:pPr indent="0" marL="0">
-              <a:buNone/>
-            </a:pPr>
-            <a:r>
-              <a:rPr lang="en-US" sz="1250" b="1" spc="100" kern="0" dirty="0">
+            <a:pPr marL="0" indent="0">
+              <a:buNone/>
+            </a:pPr>
+            <a:r>
+              <a:rPr lang="en-US" sz="1250" b="1" kern="0" spc="100" dirty="0">
                 <a:solidFill>
                   <a:srgbClr val="13263B"/>
                 </a:solidFill>
@@ -10730,7 +10439,7 @@
           <a:bodyPr wrap="square" lIns="0" tIns="0" rIns="0" bIns="0" rtlCol="0" anchor="ctr"/>
           <a:lstStyle/>
           <a:p>
-            <a:pPr indent="0" marL="0">
+            <a:pPr marL="0" indent="0">
               <a:buNone/>
             </a:pPr>
             <a:r>
@@ -10789,7 +10498,7 @@
           <a:bodyPr wrap="square" lIns="0" tIns="0" rIns="0" bIns="0" rtlCol="0" anchor="ctr"/>
           <a:lstStyle/>
           <a:p>
-            <a:pPr indent="0" marL="0">
+            <a:pPr marL="0" indent="0">
               <a:buNone/>
             </a:pPr>
             <a:r>
@@ -10848,7 +10557,7 @@
           <a:bodyPr wrap="square" lIns="0" tIns="0" rIns="0" bIns="0" rtlCol="0" anchor="ctr"/>
           <a:lstStyle/>
           <a:p>
-            <a:pPr indent="0" marL="0">
+            <a:pPr marL="0" indent="0">
               <a:buNone/>
             </a:pPr>
             <a:r>
@@ -10907,7 +10616,7 @@
           <a:bodyPr wrap="square" lIns="0" tIns="0" rIns="0" bIns="0" rtlCol="0" anchor="ctr"/>
           <a:lstStyle/>
           <a:p>
-            <a:pPr indent="0" marL="0">
+            <a:pPr marL="0" indent="0">
               <a:buNone/>
             </a:pPr>
             <a:r>
@@ -10966,7 +10675,7 @@
           <a:bodyPr wrap="square" lIns="0" tIns="0" rIns="0" bIns="0" rtlCol="0" anchor="ctr"/>
           <a:lstStyle/>
           <a:p>
-            <a:pPr indent="0" marL="0">
+            <a:pPr marL="0" indent="0">
               <a:buNone/>
             </a:pPr>
             <a:r>
@@ -11005,7 +10714,7 @@
           <a:bodyPr wrap="square" lIns="0" tIns="0" rIns="0" bIns="0" rtlCol="0" anchor="ctr"/>
           <a:lstStyle/>
           <a:p>
-            <a:pPr indent="0" marL="0">
+            <a:pPr marL="0" indent="0">
               <a:buNone/>
             </a:pPr>
             <a:r>
@@ -11044,7 +10753,7 @@
           <a:bodyPr wrap="square" lIns="0" tIns="0" rIns="0" bIns="0" rtlCol="0" anchor="ctr"/>
           <a:lstStyle/>
           <a:p>
-            <a:pPr indent="0" marL="0">
+            <a:pPr marL="0" indent="0">
               <a:buNone/>
             </a:pPr>
             <a:r>
@@ -11058,9 +10767,6 @@
               </a:rPr>
               <a:t>SeaWatch</a:t>
             </a:r>
-            <a:pPr indent="0" marL="0">
-              <a:buNone/>
-            </a:pPr>
             <a:r>
               <a:rPr lang="en-US" sz="900" dirty="0">
                 <a:solidFill>
@@ -11097,7 +10803,7 @@
           <a:bodyPr wrap="square" rtlCol="0" anchor="ctr"/>
           <a:lstStyle/>
           <a:p>
-            <a:pPr algn="r" indent="0" marL="0">
+            <a:pPr marL="0" indent="0" algn="r">
               <a:buNone/>
             </a:pPr>
             <a:r>
@@ -11131,6 +10837,7 @@
         <a:solidFill>
           <a:srgbClr val="FFFFFF"/>
         </a:solidFill>
+        <a:effectLst/>
       </p:bgPr>
     </p:bg>
     <p:spTree>
@@ -11168,11 +10875,11 @@
           <a:bodyPr wrap="square" lIns="0" tIns="0" rIns="0" bIns="0" rtlCol="0" anchor="ctr"/>
           <a:lstStyle/>
           <a:p>
-            <a:pPr indent="0" marL="0">
-              <a:buNone/>
-            </a:pPr>
-            <a:r>
-              <a:rPr lang="en-US" sz="1250" b="1" spc="200" kern="0" dirty="0">
+            <a:pPr marL="0" indent="0">
+              <a:buNone/>
+            </a:pPr>
+            <a:r>
+              <a:rPr lang="en-US" sz="1250" b="1" kern="0" spc="200" dirty="0">
                 <a:solidFill>
                   <a:srgbClr val="2E6FB0"/>
                 </a:solidFill>
@@ -11207,7 +10914,7 @@
           <a:bodyPr wrap="square" lIns="0" tIns="0" rIns="0" bIns="0" rtlCol="0" anchor="ctr"/>
           <a:lstStyle/>
           <a:p>
-            <a:pPr indent="0" marL="0">
+            <a:pPr marL="0" indent="0">
               <a:buNone/>
             </a:pPr>
             <a:r>
@@ -11246,7 +10953,7 @@
           </a:solidFill>
           <a:ln/>
           <a:effectLst>
-            <a:outerShdw sx="100000" sy="100000" kx="0" ky="0" algn="bl" rotWithShape="0" blurRad="101600" dist="38100" dir="5400000">
+            <a:outerShdw blurRad="101600" dist="38100" dir="5400000" algn="bl" rotWithShape="0">
               <a:srgbClr val="0A1626">
                 <a:alpha val="10000"/>
               </a:srgbClr>
@@ -11275,7 +10982,7 @@
           <a:bodyPr wrap="square" lIns="0" tIns="0" rIns="0" bIns="0" rtlCol="0" anchor="ctr"/>
           <a:lstStyle/>
           <a:p>
-            <a:pPr indent="0" marL="0">
+            <a:pPr marL="0" indent="0">
               <a:buNone/>
             </a:pPr>
             <a:r>
@@ -11314,7 +11021,7 @@
           <a:bodyPr wrap="square" lIns="0" tIns="0" rIns="0" bIns="0" rtlCol="0" anchor="t"/>
           <a:lstStyle/>
           <a:p>
-            <a:pPr indent="0" marL="0">
+            <a:pPr marL="0" indent="0">
               <a:buNone/>
             </a:pPr>
             <a:r>
@@ -11353,7 +11060,7 @@
           </a:solidFill>
           <a:ln/>
           <a:effectLst>
-            <a:outerShdw sx="100000" sy="100000" kx="0" ky="0" algn="bl" rotWithShape="0" blurRad="101600" dist="38100" dir="5400000">
+            <a:outerShdw blurRad="101600" dist="38100" dir="5400000" algn="bl" rotWithShape="0">
               <a:srgbClr val="0A1626">
                 <a:alpha val="10000"/>
               </a:srgbClr>
@@ -11382,7 +11089,7 @@
           <a:bodyPr wrap="square" lIns="0" tIns="0" rIns="0" bIns="0" rtlCol="0" anchor="ctr"/>
           <a:lstStyle/>
           <a:p>
-            <a:pPr indent="0" marL="0">
+            <a:pPr marL="0" indent="0">
               <a:buNone/>
             </a:pPr>
             <a:r>
@@ -11421,7 +11128,7 @@
           <a:bodyPr wrap="square" lIns="0" tIns="0" rIns="0" bIns="0" rtlCol="0" anchor="t"/>
           <a:lstStyle/>
           <a:p>
-            <a:pPr indent="0" marL="0">
+            <a:pPr marL="0" indent="0">
               <a:buNone/>
             </a:pPr>
             <a:r>
@@ -11460,7 +11167,7 @@
           </a:solidFill>
           <a:ln/>
           <a:effectLst>
-            <a:outerShdw sx="100000" sy="100000" kx="0" ky="0" algn="bl" rotWithShape="0" blurRad="101600" dist="38100" dir="5400000">
+            <a:outerShdw blurRad="101600" dist="38100" dir="5400000" algn="bl" rotWithShape="0">
               <a:srgbClr val="0A1626">
                 <a:alpha val="10000"/>
               </a:srgbClr>
@@ -11489,7 +11196,7 @@
           <a:bodyPr wrap="square" lIns="0" tIns="0" rIns="0" bIns="0" rtlCol="0" anchor="ctr"/>
           <a:lstStyle/>
           <a:p>
-            <a:pPr indent="0" marL="0">
+            <a:pPr marL="0" indent="0">
               <a:buNone/>
             </a:pPr>
             <a:r>
@@ -11528,7 +11235,7 @@
           <a:bodyPr wrap="square" lIns="0" tIns="0" rIns="0" bIns="0" rtlCol="0" anchor="t"/>
           <a:lstStyle/>
           <a:p>
-            <a:pPr indent="0" marL="0">
+            <a:pPr marL="0" indent="0">
               <a:buNone/>
             </a:pPr>
             <a:r>
@@ -11567,7 +11274,7 @@
           </a:solidFill>
           <a:ln/>
           <a:effectLst>
-            <a:outerShdw sx="100000" sy="100000" kx="0" ky="0" algn="bl" rotWithShape="0" blurRad="101600" dist="38100" dir="5400000">
+            <a:outerShdw blurRad="101600" dist="38100" dir="5400000" algn="bl" rotWithShape="0">
               <a:srgbClr val="0A1626">
                 <a:alpha val="10000"/>
               </a:srgbClr>
@@ -11596,7 +11303,7 @@
           <a:bodyPr wrap="square" lIns="0" tIns="0" rIns="0" bIns="0" rtlCol="0" anchor="ctr"/>
           <a:lstStyle/>
           <a:p>
-            <a:pPr indent="0" marL="0">
+            <a:pPr marL="0" indent="0">
               <a:buNone/>
             </a:pPr>
             <a:r>
@@ -11635,7 +11342,7 @@
           <a:bodyPr wrap="square" lIns="0" tIns="0" rIns="0" bIns="0" rtlCol="0" anchor="t"/>
           <a:lstStyle/>
           <a:p>
-            <a:pPr indent="0" marL="0">
+            <a:pPr marL="0" indent="0">
               <a:buNone/>
             </a:pPr>
             <a:r>
@@ -11674,7 +11381,7 @@
           <a:bodyPr wrap="square" lIns="0" tIns="0" rIns="0" bIns="0" rtlCol="0" anchor="ctr"/>
           <a:lstStyle/>
           <a:p>
-            <a:pPr indent="0" marL="0">
+            <a:pPr marL="0" indent="0">
               <a:buNone/>
             </a:pPr>
             <a:r>
@@ -11688,9 +11395,6 @@
               </a:rPr>
               <a:t>SeaWatch</a:t>
             </a:r>
-            <a:pPr indent="0" marL="0">
-              <a:buNone/>
-            </a:pPr>
             <a:r>
               <a:rPr lang="en-US" sz="900" dirty="0">
                 <a:solidFill>
@@ -11727,7 +11431,7 @@
           <a:bodyPr wrap="square" rtlCol="0" anchor="ctr"/>
           <a:lstStyle/>
           <a:p>
-            <a:pPr algn="r" indent="0" marL="0">
+            <a:pPr marL="0" indent="0" algn="r">
               <a:buNone/>
             </a:pPr>
             <a:r>
@@ -11761,6 +11465,7 @@
         <a:solidFill>
           <a:srgbClr val="0A1A2E"/>
         </a:solidFill>
+        <a:effectLst/>
       </p:bgPr>
     </p:bg>
     <p:spTree>
@@ -11798,11 +11503,11 @@
           <a:bodyPr wrap="square" lIns="0" tIns="0" rIns="0" bIns="0" rtlCol="0" anchor="ctr"/>
           <a:lstStyle/>
           <a:p>
-            <a:pPr indent="0" marL="0">
-              <a:buNone/>
-            </a:pPr>
-            <a:r>
-              <a:rPr lang="en-US" sz="1250" b="1" spc="200" kern="0" dirty="0">
+            <a:pPr marL="0" indent="0">
+              <a:buNone/>
+            </a:pPr>
+            <a:r>
+              <a:rPr lang="en-US" sz="1250" b="1" kern="0" spc="200" dirty="0">
                 <a:solidFill>
                   <a:srgbClr val="F2C200"/>
                 </a:solidFill>
@@ -11837,7 +11542,7 @@
           <a:bodyPr wrap="square" lIns="0" tIns="0" rIns="0" bIns="0" rtlCol="0" anchor="ctr"/>
           <a:lstStyle/>
           <a:p>
-            <a:pPr indent="0" marL="0">
+            <a:pPr marL="0" indent="0">
               <a:buNone/>
             </a:pPr>
             <a:r>
@@ -11876,7 +11581,7 @@
           <a:bodyPr wrap="square" lIns="0" tIns="0" rIns="0" bIns="0" rtlCol="0" anchor="ctr"/>
           <a:lstStyle/>
           <a:p>
-            <a:pPr indent="0" marL="0">
+            <a:pPr marL="0" indent="0">
               <a:buNone/>
             </a:pPr>
             <a:r>
@@ -11915,7 +11620,7 @@
           </a:solidFill>
           <a:ln/>
           <a:effectLst>
-            <a:outerShdw sx="100000" sy="100000" kx="0" ky="0" algn="bl" rotWithShape="0" blurRad="101600" dist="38100" dir="5400000">
+            <a:outerShdw blurRad="101600" dist="38100" dir="5400000" algn="bl" rotWithShape="0">
               <a:srgbClr val="0A1626">
                 <a:alpha val="10000"/>
               </a:srgbClr>
@@ -11964,7 +11669,7 @@
           <a:bodyPr wrap="square" lIns="0" tIns="0" rIns="0" bIns="0" rtlCol="0" anchor="ctr"/>
           <a:lstStyle/>
           <a:p>
-            <a:pPr algn="ctr" indent="0" marL="0">
+            <a:pPr marL="0" indent="0" algn="ctr">
               <a:buNone/>
             </a:pPr>
             <a:r>
@@ -12003,7 +11708,7 @@
           <a:bodyPr wrap="square" lIns="0" tIns="0" rIns="0" bIns="0" rtlCol="0" anchor="ctr"/>
           <a:lstStyle/>
           <a:p>
-            <a:pPr algn="ctr" indent="0" marL="0">
+            <a:pPr marL="0" indent="0" algn="ctr">
               <a:buNone/>
             </a:pPr>
             <a:r>
@@ -12042,7 +11747,7 @@
           <a:bodyPr wrap="square" lIns="0" tIns="0" rIns="0" bIns="0" rtlCol="0" anchor="t"/>
           <a:lstStyle/>
           <a:p>
-            <a:pPr algn="ctr" indent="0" marL="0">
+            <a:pPr marL="0" indent="0" algn="ctr">
               <a:buNone/>
             </a:pPr>
             <a:r>
@@ -12081,7 +11786,7 @@
           </a:solidFill>
           <a:ln/>
           <a:effectLst>
-            <a:outerShdw sx="100000" sy="100000" kx="0" ky="0" algn="bl" rotWithShape="0" blurRad="101600" dist="38100" dir="5400000">
+            <a:outerShdw blurRad="101600" dist="38100" dir="5400000" algn="bl" rotWithShape="0">
               <a:srgbClr val="0A1626">
                 <a:alpha val="10000"/>
               </a:srgbClr>
@@ -12130,7 +11835,7 @@
           <a:bodyPr wrap="square" lIns="0" tIns="0" rIns="0" bIns="0" rtlCol="0" anchor="ctr"/>
           <a:lstStyle/>
           <a:p>
-            <a:pPr algn="ctr" indent="0" marL="0">
+            <a:pPr marL="0" indent="0" algn="ctr">
               <a:buNone/>
             </a:pPr>
             <a:r>
@@ -12169,7 +11874,7 @@
           <a:bodyPr wrap="square" lIns="0" tIns="0" rIns="0" bIns="0" rtlCol="0" anchor="ctr"/>
           <a:lstStyle/>
           <a:p>
-            <a:pPr algn="ctr" indent="0" marL="0">
+            <a:pPr marL="0" indent="0" algn="ctr">
               <a:buNone/>
             </a:pPr>
             <a:r>
@@ -12208,7 +11913,7 @@
           <a:bodyPr wrap="square" lIns="0" tIns="0" rIns="0" bIns="0" rtlCol="0" anchor="t"/>
           <a:lstStyle/>
           <a:p>
-            <a:pPr algn="ctr" indent="0" marL="0">
+            <a:pPr marL="0" indent="0" algn="ctr">
               <a:buNone/>
             </a:pPr>
             <a:r>
@@ -12247,7 +11952,7 @@
           </a:solidFill>
           <a:ln/>
           <a:effectLst>
-            <a:outerShdw sx="100000" sy="100000" kx="0" ky="0" algn="bl" rotWithShape="0" blurRad="101600" dist="38100" dir="5400000">
+            <a:outerShdw blurRad="101600" dist="38100" dir="5400000" algn="bl" rotWithShape="0">
               <a:srgbClr val="0A1626">
                 <a:alpha val="10000"/>
               </a:srgbClr>
@@ -12296,7 +12001,7 @@
           <a:bodyPr wrap="square" lIns="0" tIns="0" rIns="0" bIns="0" rtlCol="0" anchor="ctr"/>
           <a:lstStyle/>
           <a:p>
-            <a:pPr algn="ctr" indent="0" marL="0">
+            <a:pPr marL="0" indent="0" algn="ctr">
               <a:buNone/>
             </a:pPr>
             <a:r>
@@ -12335,7 +12040,7 @@
           <a:bodyPr wrap="square" lIns="0" tIns="0" rIns="0" bIns="0" rtlCol="0" anchor="ctr"/>
           <a:lstStyle/>
           <a:p>
-            <a:pPr algn="ctr" indent="0" marL="0">
+            <a:pPr marL="0" indent="0" algn="ctr">
               <a:buNone/>
             </a:pPr>
             <a:r>
@@ -12374,7 +12079,7 @@
           <a:bodyPr wrap="square" lIns="0" tIns="0" rIns="0" bIns="0" rtlCol="0" anchor="t"/>
           <a:lstStyle/>
           <a:p>
-            <a:pPr algn="ctr" indent="0" marL="0">
+            <a:pPr marL="0" indent="0" algn="ctr">
               <a:buNone/>
             </a:pPr>
             <a:r>
@@ -12413,7 +12118,7 @@
           </a:solidFill>
           <a:ln/>
           <a:effectLst>
-            <a:outerShdw sx="100000" sy="100000" kx="0" ky="0" algn="bl" rotWithShape="0" blurRad="101600" dist="38100" dir="5400000">
+            <a:outerShdw blurRad="101600" dist="38100" dir="5400000" algn="bl" rotWithShape="0">
               <a:srgbClr val="0A1626">
                 <a:alpha val="10000"/>
               </a:srgbClr>
@@ -12462,7 +12167,7 @@
           <a:bodyPr wrap="square" lIns="0" tIns="0" rIns="0" bIns="0" rtlCol="0" anchor="ctr"/>
           <a:lstStyle/>
           <a:p>
-            <a:pPr algn="ctr" indent="0" marL="0">
+            <a:pPr marL="0" indent="0" algn="ctr">
               <a:buNone/>
             </a:pPr>
             <a:r>
@@ -12501,7 +12206,7 @@
           <a:bodyPr wrap="square" lIns="0" tIns="0" rIns="0" bIns="0" rtlCol="0" anchor="ctr"/>
           <a:lstStyle/>
           <a:p>
-            <a:pPr algn="ctr" indent="0" marL="0">
+            <a:pPr marL="0" indent="0" algn="ctr">
               <a:buNone/>
             </a:pPr>
             <a:r>
@@ -12540,7 +12245,7 @@
           <a:bodyPr wrap="square" lIns="0" tIns="0" rIns="0" bIns="0" rtlCol="0" anchor="t"/>
           <a:lstStyle/>
           <a:p>
-            <a:pPr algn="ctr" indent="0" marL="0">
+            <a:pPr marL="0" indent="0" algn="ctr">
               <a:buNone/>
             </a:pPr>
             <a:r>
@@ -12579,7 +12284,7 @@
           </a:solidFill>
           <a:ln/>
           <a:effectLst>
-            <a:outerShdw sx="100000" sy="100000" kx="0" ky="0" algn="bl" rotWithShape="0" blurRad="101600" dist="38100" dir="5400000">
+            <a:outerShdw blurRad="101600" dist="38100" dir="5400000" algn="bl" rotWithShape="0">
               <a:srgbClr val="0A1626">
                 <a:alpha val="10000"/>
               </a:srgbClr>
@@ -12628,7 +12333,7 @@
           <a:bodyPr wrap="square" lIns="0" tIns="0" rIns="0" bIns="0" rtlCol="0" anchor="ctr"/>
           <a:lstStyle/>
           <a:p>
-            <a:pPr algn="ctr" indent="0" marL="0">
+            <a:pPr marL="0" indent="0" algn="ctr">
               <a:buNone/>
             </a:pPr>
             <a:r>
@@ -12667,7 +12372,7 @@
           <a:bodyPr wrap="square" lIns="0" tIns="0" rIns="0" bIns="0" rtlCol="0" anchor="ctr"/>
           <a:lstStyle/>
           <a:p>
-            <a:pPr algn="ctr" indent="0" marL="0">
+            <a:pPr marL="0" indent="0" algn="ctr">
               <a:buNone/>
             </a:pPr>
             <a:r>
@@ -12706,7 +12411,7 @@
           <a:bodyPr wrap="square" lIns="0" tIns="0" rIns="0" bIns="0" rtlCol="0" anchor="t"/>
           <a:lstStyle/>
           <a:p>
-            <a:pPr algn="ctr" indent="0" marL="0">
+            <a:pPr marL="0" indent="0" algn="ctr">
               <a:buNone/>
             </a:pPr>
             <a:r>
@@ -12745,7 +12450,7 @@
           <a:bodyPr wrap="square" lIns="0" tIns="0" rIns="0" bIns="0" rtlCol="0" anchor="ctr"/>
           <a:lstStyle/>
           <a:p>
-            <a:pPr indent="0" marL="0">
+            <a:pPr marL="0" indent="0">
               <a:buNone/>
             </a:pPr>
             <a:r>
@@ -12784,7 +12489,7 @@
           <a:bodyPr wrap="square" lIns="0" tIns="0" rIns="0" bIns="0" rtlCol="0" anchor="ctr"/>
           <a:lstStyle/>
           <a:p>
-            <a:pPr indent="0" marL="0">
+            <a:pPr marL="0" indent="0">
               <a:buNone/>
             </a:pPr>
             <a:r>
@@ -12798,9 +12503,6 @@
               </a:rPr>
               <a:t>SeaWatch</a:t>
             </a:r>
-            <a:pPr indent="0" marL="0">
-              <a:buNone/>
-            </a:pPr>
             <a:r>
               <a:rPr lang="en-US" sz="900" dirty="0">
                 <a:solidFill>
@@ -12837,7 +12539,7 @@
           <a:bodyPr wrap="square" rtlCol="0" anchor="ctr"/>
           <a:lstStyle/>
           <a:p>
-            <a:pPr algn="r" indent="0" marL="0">
+            <a:pPr marL="0" indent="0" algn="r">
               <a:buNone/>
             </a:pPr>
             <a:r>
@@ -12871,6 +12573,7 @@
         <a:solidFill>
           <a:srgbClr val="FFFFFF"/>
         </a:solidFill>
+        <a:effectLst/>
       </p:bgPr>
     </p:bg>
     <p:spTree>
@@ -12908,11 +12611,11 @@
           <a:bodyPr wrap="square" lIns="0" tIns="0" rIns="0" bIns="0" rtlCol="0" anchor="ctr"/>
           <a:lstStyle/>
           <a:p>
-            <a:pPr indent="0" marL="0">
-              <a:buNone/>
-            </a:pPr>
-            <a:r>
-              <a:rPr lang="en-US" sz="1250" b="1" spc="200" kern="0" dirty="0">
+            <a:pPr marL="0" indent="0">
+              <a:buNone/>
+            </a:pPr>
+            <a:r>
+              <a:rPr lang="en-US" sz="1250" b="1" kern="0" spc="200" dirty="0">
                 <a:solidFill>
                   <a:srgbClr val="C8102E"/>
                 </a:solidFill>
@@ -12947,7 +12650,7 @@
           <a:bodyPr wrap="square" lIns="0" tIns="0" rIns="0" bIns="0" rtlCol="0" anchor="ctr"/>
           <a:lstStyle/>
           <a:p>
-            <a:pPr indent="0" marL="0">
+            <a:pPr marL="0" indent="0">
               <a:buNone/>
             </a:pPr>
             <a:r>
@@ -12974,23 +12677,41 @@
           <p:nvPr>
             <p:extLst>
               <p:ext uri="{D42A27DB-BD31-4B8C-83A1-F6EECF244321}">
-                <p14:modId xmlns:p14="http://schemas.microsoft.com/office/powerpoint/2010/main" val="1579011935"/>
+                <p14:modId xmlns:p14="http://schemas.microsoft.com/office/powerpoint/2010/main" val="2844133648"/>
               </p:ext>
             </p:extLst>
           </p:nvPr>
         </p:nvGraphicFramePr>
         <p:xfrm>
           <a:off x="548640" y="1783080"/>
-          <a:ext cx="11091672" cy="914400"/>
+          <a:ext cx="11091672" cy="3931920"/>
         </p:xfrm>
         <a:graphic>
           <a:graphicData uri="http://schemas.openxmlformats.org/drawingml/2006/table">
             <a:tbl>
               <a:tblPr/>
               <a:tblGrid>
-                <a:gridCol w="2743200"/>
-                <a:gridCol w="6062472"/>
-                <a:gridCol w="2286000"/>
+                <a:gridCol w="2743200">
+                  <a:extLst>
+                    <a:ext uri="{9D8B030D-6E8A-4147-A177-3AD203B41FA5}">
+                      <a16:colId xmlns:a16="http://schemas.microsoft.com/office/drawing/2014/main" val="20000"/>
+                    </a:ext>
+                  </a:extLst>
+                </a:gridCol>
+                <a:gridCol w="6062472">
+                  <a:extLst>
+                    <a:ext uri="{9D8B030D-6E8A-4147-A177-3AD203B41FA5}">
+                      <a16:colId xmlns:a16="http://schemas.microsoft.com/office/drawing/2014/main" val="20001"/>
+                    </a:ext>
+                  </a:extLst>
+                </a:gridCol>
+                <a:gridCol w="2286000">
+                  <a:extLst>
+                    <a:ext uri="{9D8B030D-6E8A-4147-A177-3AD203B41FA5}">
+                      <a16:colId xmlns:a16="http://schemas.microsoft.com/office/drawing/2014/main" val="20002"/>
+                    </a:ext>
+                  </a:extLst>
+                </a:gridCol>
               </a:tblGrid>
               <a:tr h="384048">
                 <a:tc>
@@ -12998,7 +12719,7 @@
                     <a:bodyPr/>
                     <a:lstStyle/>
                     <a:p>
-                      <a:pPr algn="l" indent="0" marL="0">
+                      <a:pPr marL="0" indent="0" algn="l">
                         <a:buNone/>
                       </a:pPr>
                       <a:r>
@@ -13066,7 +12787,7 @@
                     <a:bodyPr/>
                     <a:lstStyle/>
                     <a:p>
-                      <a:pPr algn="l" indent="0" marL="0">
+                      <a:pPr marL="0" indent="0" algn="l">
                         <a:buNone/>
                       </a:pPr>
                       <a:r>
@@ -13134,7 +12855,7 @@
                     <a:bodyPr/>
                     <a:lstStyle/>
                     <a:p>
-                      <a:pPr algn="l" indent="0" marL="0">
+                      <a:pPr marL="0" indent="0" algn="l">
                         <a:buNone/>
                       </a:pPr>
                       <a:r>
@@ -13197,6 +12918,11 @@
                     </a:solidFill>
                   </a:tcPr>
                 </a:tc>
+                <a:extLst>
+                  <a:ext uri="{0D108BD9-81ED-4DB2-BD59-A6C34878D82A}">
+                    <a16:rowId xmlns:a16="http://schemas.microsoft.com/office/drawing/2014/main" val="10000"/>
+                  </a:ext>
+                </a:extLst>
               </a:tr>
               <a:tr h="566928">
                 <a:tc>
@@ -13204,7 +12930,7 @@
                     <a:bodyPr/>
                     <a:lstStyle/>
                     <a:p>
-                      <a:pPr algn="l" indent="0" marL="0">
+                      <a:pPr marL="0" indent="0" algn="l">
                         <a:buNone/>
                       </a:pPr>
                       <a:r>
@@ -13272,7 +12998,7 @@
                     <a:bodyPr/>
                     <a:lstStyle/>
                     <a:p>
-                      <a:pPr algn="l" indent="0" marL="0">
+                      <a:pPr marL="0" indent="0" algn="l">
                         <a:buNone/>
                       </a:pPr>
                       <a:r>
@@ -13340,7 +13066,7 @@
                     <a:bodyPr/>
                     <a:lstStyle/>
                     <a:p>
-                      <a:pPr algn="l" indent="0" marL="0">
+                      <a:pPr marL="0" indent="0" algn="l">
                         <a:buNone/>
                       </a:pPr>
                       <a:r>
@@ -13403,6 +13129,11 @@
                     </a:solidFill>
                   </a:tcPr>
                 </a:tc>
+                <a:extLst>
+                  <a:ext uri="{0D108BD9-81ED-4DB2-BD59-A6C34878D82A}">
+                    <a16:rowId xmlns:a16="http://schemas.microsoft.com/office/drawing/2014/main" val="10001"/>
+                  </a:ext>
+                </a:extLst>
               </a:tr>
               <a:tr h="566928">
                 <a:tc>
@@ -13410,7 +13141,7 @@
                     <a:bodyPr/>
                     <a:lstStyle/>
                     <a:p>
-                      <a:pPr algn="l" indent="0" marL="0">
+                      <a:pPr marL="0" indent="0" algn="l">
                         <a:buNone/>
                       </a:pPr>
                       <a:r>
@@ -13478,7 +13209,7 @@
                     <a:bodyPr/>
                     <a:lstStyle/>
                     <a:p>
-                      <a:pPr algn="l" indent="0" marL="0">
+                      <a:pPr marL="0" indent="0" algn="l">
                         <a:buNone/>
                       </a:pPr>
                       <a:r>
@@ -13546,7 +13277,7 @@
                     <a:bodyPr/>
                     <a:lstStyle/>
                     <a:p>
-                      <a:pPr algn="l" indent="0" marL="0">
+                      <a:pPr marL="0" indent="0" algn="l">
                         <a:buNone/>
                       </a:pPr>
                       <a:r>
@@ -13609,6 +13340,11 @@
                     </a:solidFill>
                   </a:tcPr>
                 </a:tc>
+                <a:extLst>
+                  <a:ext uri="{0D108BD9-81ED-4DB2-BD59-A6C34878D82A}">
+                    <a16:rowId xmlns:a16="http://schemas.microsoft.com/office/drawing/2014/main" val="10002"/>
+                  </a:ext>
+                </a:extLst>
               </a:tr>
               <a:tr h="566928">
                 <a:tc>
@@ -13616,7 +13352,7 @@
                     <a:bodyPr/>
                     <a:lstStyle/>
                     <a:p>
-                      <a:pPr algn="l" indent="0" marL="0">
+                      <a:pPr marL="0" indent="0" algn="l">
                         <a:buNone/>
                       </a:pPr>
                       <a:r>
@@ -13684,7 +13420,7 @@
                     <a:bodyPr/>
                     <a:lstStyle/>
                     <a:p>
-                      <a:pPr algn="l" indent="0" marL="0">
+                      <a:pPr marL="0" indent="0" algn="l">
                         <a:buNone/>
                       </a:pPr>
                       <a:r>
@@ -13752,7 +13488,7 @@
                     <a:bodyPr/>
                     <a:lstStyle/>
                     <a:p>
-                      <a:pPr algn="l" indent="0" marL="0">
+                      <a:pPr marL="0" indent="0" algn="l">
                         <a:buNone/>
                       </a:pPr>
                       <a:r>
@@ -13815,6 +13551,11 @@
                     </a:solidFill>
                   </a:tcPr>
                 </a:tc>
+                <a:extLst>
+                  <a:ext uri="{0D108BD9-81ED-4DB2-BD59-A6C34878D82A}">
+                    <a16:rowId xmlns:a16="http://schemas.microsoft.com/office/drawing/2014/main" val="10003"/>
+                  </a:ext>
+                </a:extLst>
               </a:tr>
               <a:tr h="713232">
                 <a:tc>
@@ -13822,7 +13563,7 @@
                     <a:bodyPr/>
                     <a:lstStyle/>
                     <a:p>
-                      <a:pPr algn="l" indent="0" marL="0">
+                      <a:pPr marL="0" indent="0" algn="l">
                         <a:buNone/>
                       </a:pPr>
                       <a:r>
@@ -13890,7 +13631,7 @@
                     <a:bodyPr/>
                     <a:lstStyle/>
                     <a:p>
-                      <a:pPr algn="l" indent="0" marL="0">
+                      <a:pPr marL="0" indent="0" algn="l">
                         <a:buNone/>
                       </a:pPr>
                       <a:r>
@@ -13958,7 +13699,7 @@
                     <a:bodyPr/>
                     <a:lstStyle/>
                     <a:p>
-                      <a:pPr algn="l" indent="0" marL="0">
+                      <a:pPr marL="0" indent="0" algn="l">
                         <a:buNone/>
                       </a:pPr>
                       <a:r>
@@ -14021,6 +13762,11 @@
                     </a:solidFill>
                   </a:tcPr>
                 </a:tc>
+                <a:extLst>
+                  <a:ext uri="{0D108BD9-81ED-4DB2-BD59-A6C34878D82A}">
+                    <a16:rowId xmlns:a16="http://schemas.microsoft.com/office/drawing/2014/main" val="10004"/>
+                  </a:ext>
+                </a:extLst>
               </a:tr>
               <a:tr h="566928">
                 <a:tc>
@@ -14028,7 +13774,7 @@
                     <a:bodyPr/>
                     <a:lstStyle/>
                     <a:p>
-                      <a:pPr algn="l" indent="0" marL="0">
+                      <a:pPr marL="0" indent="0" algn="l">
                         <a:buNone/>
                       </a:pPr>
                       <a:r>
@@ -14096,7 +13842,7 @@
                     <a:bodyPr/>
                     <a:lstStyle/>
                     <a:p>
-                      <a:pPr algn="l" indent="0" marL="0">
+                      <a:pPr marL="0" indent="0" algn="l">
                         <a:buNone/>
                       </a:pPr>
                       <a:r>
@@ -14108,7 +13854,62 @@
                           <a:ea typeface="Calibri" pitchFamily="34" charset="-122"/>
                           <a:cs typeface="Calibri" pitchFamily="34" charset="-120"/>
                         </a:rPr>
-                        <a:t>Two slow (&lt;3 kn) vessels within 0.6 NM offshore, outside a designated anchorage</a:t>
+                        <a:t>Two slow </a:t>
+                      </a:r>
+                      <a:r>
+                        <a:rPr lang="en-US" sz="1150" dirty="0" smtClean="0">
+                          <a:solidFill>
+                            <a:srgbClr val="5C6E82"/>
+                          </a:solidFill>
+                          <a:latin typeface="Calibri" pitchFamily="34" charset="0"/>
+                          <a:ea typeface="Calibri" pitchFamily="34" charset="-122"/>
+                          <a:cs typeface="Calibri" pitchFamily="34" charset="-120"/>
+                        </a:rPr>
+                        <a:t>(&lt;1.2 </a:t>
+                      </a:r>
+                      <a:r>
+                        <a:rPr lang="en-US" sz="1150" dirty="0">
+                          <a:solidFill>
+                            <a:srgbClr val="5C6E82"/>
+                          </a:solidFill>
+                          <a:latin typeface="Calibri" pitchFamily="34" charset="0"/>
+                          <a:ea typeface="Calibri" pitchFamily="34" charset="-122"/>
+                          <a:cs typeface="Calibri" pitchFamily="34" charset="-120"/>
+                        </a:rPr>
+                        <a:t>kn) vessels </a:t>
+                      </a:r>
+                      <a:r>
+                        <a:rPr lang="en-US" sz="1150">
+                          <a:solidFill>
+                            <a:srgbClr val="5C6E82"/>
+                          </a:solidFill>
+                          <a:latin typeface="Calibri" pitchFamily="34" charset="0"/>
+                          <a:ea typeface="Calibri" pitchFamily="34" charset="-122"/>
+                          <a:cs typeface="Calibri" pitchFamily="34" charset="-120"/>
+                        </a:rPr>
+                        <a:t>within </a:t>
+                      </a:r>
+                      <a:r>
+                        <a:rPr lang="en-US" sz="1150" smtClean="0">
+                          <a:solidFill>
+                            <a:srgbClr val="5C6E82"/>
+                          </a:solidFill>
+                          <a:latin typeface="Calibri" pitchFamily="34" charset="0"/>
+                          <a:ea typeface="Calibri" pitchFamily="34" charset="-122"/>
+                          <a:cs typeface="Calibri" pitchFamily="34" charset="-120"/>
+                        </a:rPr>
+                        <a:t>0.3 </a:t>
+                      </a:r>
+                      <a:r>
+                        <a:rPr lang="en-US" sz="1150" dirty="0">
+                          <a:solidFill>
+                            <a:srgbClr val="5C6E82"/>
+                          </a:solidFill>
+                          <a:latin typeface="Calibri" pitchFamily="34" charset="0"/>
+                          <a:ea typeface="Calibri" pitchFamily="34" charset="-122"/>
+                          <a:cs typeface="Calibri" pitchFamily="34" charset="-120"/>
+                        </a:rPr>
+                        <a:t>NM offshore, outside a designated anchorage</a:t>
                       </a:r>
                       <a:endParaRPr lang="en-US" sz="1150" dirty="0">
                         <a:latin typeface="Calibri" charset="0"/>
@@ -14164,7 +13965,7 @@
                     <a:bodyPr/>
                     <a:lstStyle/>
                     <a:p>
-                      <a:pPr algn="l" indent="0" marL="0">
+                      <a:pPr marL="0" indent="0" algn="l">
                         <a:buNone/>
                       </a:pPr>
                       <a:r>
@@ -14227,6 +14028,11 @@
                     </a:solidFill>
                   </a:tcPr>
                 </a:tc>
+                <a:extLst>
+                  <a:ext uri="{0D108BD9-81ED-4DB2-BD59-A6C34878D82A}">
+                    <a16:rowId xmlns:a16="http://schemas.microsoft.com/office/drawing/2014/main" val="10005"/>
+                  </a:ext>
+                </a:extLst>
               </a:tr>
               <a:tr h="566928">
                 <a:tc>
@@ -14234,7 +14040,7 @@
                     <a:bodyPr/>
                     <a:lstStyle/>
                     <a:p>
-                      <a:pPr algn="l" indent="0" marL="0">
+                      <a:pPr marL="0" indent="0" algn="l">
                         <a:buNone/>
                       </a:pPr>
                       <a:r>
@@ -14302,7 +14108,7 @@
                     <a:bodyPr/>
                     <a:lstStyle/>
                     <a:p>
-                      <a:pPr algn="l" indent="0" marL="0">
+                      <a:pPr marL="0" indent="0" algn="l">
                         <a:buNone/>
                       </a:pPr>
                       <a:r>
@@ -14370,7 +14176,7 @@
                     <a:bodyPr/>
                     <a:lstStyle/>
                     <a:p>
-                      <a:pPr algn="l" indent="0" marL="0">
+                      <a:pPr marL="0" indent="0" algn="l">
                         <a:buNone/>
                       </a:pPr>
                       <a:r>
@@ -14433,6 +14239,11 @@
                     </a:solidFill>
                   </a:tcPr>
                 </a:tc>
+                <a:extLst>
+                  <a:ext uri="{0D108BD9-81ED-4DB2-BD59-A6C34878D82A}">
+                    <a16:rowId xmlns:a16="http://schemas.microsoft.com/office/drawing/2014/main" val="10006"/>
+                  </a:ext>
+                </a:extLst>
               </a:tr>
             </a:tbl>
           </a:graphicData>
@@ -14459,7 +14270,7 @@
           <a:bodyPr wrap="square" lIns="0" tIns="0" rIns="0" bIns="0" rtlCol="0" anchor="ctr"/>
           <a:lstStyle/>
           <a:p>
-            <a:pPr indent="0" marL="0">
+            <a:pPr marL="0" indent="0">
               <a:buNone/>
             </a:pPr>
             <a:r>
@@ -14498,7 +14309,7 @@
           <a:bodyPr wrap="square" lIns="0" tIns="0" rIns="0" bIns="0" rtlCol="0" anchor="ctr"/>
           <a:lstStyle/>
           <a:p>
-            <a:pPr indent="0" marL="0">
+            <a:pPr marL="0" indent="0">
               <a:buNone/>
             </a:pPr>
             <a:r>
@@ -14512,9 +14323,6 @@
               </a:rPr>
               <a:t>SeaWatch</a:t>
             </a:r>
-            <a:pPr indent="0" marL="0">
-              <a:buNone/>
-            </a:pPr>
             <a:r>
               <a:rPr lang="en-US" sz="900" dirty="0">
                 <a:solidFill>
@@ -14551,7 +14359,7 @@
           <a:bodyPr wrap="square" rtlCol="0" anchor="ctr"/>
           <a:lstStyle/>
           <a:p>
-            <a:pPr algn="r" indent="0" marL="0">
+            <a:pPr marL="0" indent="0" algn="r">
               <a:buNone/>
             </a:pPr>
             <a:r>
@@ -14585,6 +14393,7 @@
         <a:solidFill>
           <a:srgbClr val="FFFFFF"/>
         </a:solidFill>
+        <a:effectLst/>
       </p:bgPr>
     </p:bg>
     <p:spTree>
@@ -14622,11 +14431,11 @@
           <a:bodyPr wrap="square" lIns="0" tIns="0" rIns="0" bIns="0" rtlCol="0" anchor="ctr"/>
           <a:lstStyle/>
           <a:p>
-            <a:pPr indent="0" marL="0">
-              <a:buNone/>
-            </a:pPr>
-            <a:r>
-              <a:rPr lang="en-US" sz="1250" b="1" spc="200" kern="0" dirty="0">
+            <a:pPr marL="0" indent="0">
+              <a:buNone/>
+            </a:pPr>
+            <a:r>
+              <a:rPr lang="en-US" sz="1250" b="1" kern="0" spc="200" dirty="0">
                 <a:solidFill>
                   <a:srgbClr val="F2C200"/>
                 </a:solidFill>
@@ -14661,7 +14470,7 @@
           <a:bodyPr wrap="square" lIns="0" tIns="0" rIns="0" bIns="0" rtlCol="0" anchor="ctr"/>
           <a:lstStyle/>
           <a:p>
-            <a:pPr indent="0" marL="0">
+            <a:pPr marL="0" indent="0">
               <a:buNone/>
             </a:pPr>
             <a:r>
@@ -14700,7 +14509,7 @@
           <a:bodyPr wrap="square" lIns="0" tIns="0" rIns="0" bIns="0" rtlCol="0" anchor="ctr"/>
           <a:lstStyle/>
           <a:p>
-            <a:pPr indent="0" marL="0">
+            <a:pPr marL="0" indent="0">
               <a:buNone/>
             </a:pPr>
             <a:r>
@@ -14739,7 +14548,7 @@
           </a:solidFill>
           <a:ln/>
           <a:effectLst>
-            <a:outerShdw sx="100000" sy="100000" kx="0" ky="0" algn="bl" rotWithShape="0" blurRad="101600" dist="38100" dir="5400000">
+            <a:outerShdw blurRad="101600" dist="38100" dir="5400000" algn="bl" rotWithShape="0">
               <a:srgbClr val="0A1626">
                 <a:alpha val="10000"/>
               </a:srgbClr>
@@ -14768,11 +14577,11 @@
           <a:bodyPr wrap="square" lIns="0" tIns="0" rIns="0" bIns="0" rtlCol="0" anchor="ctr"/>
           <a:lstStyle/>
           <a:p>
-            <a:pPr indent="0" marL="0">
-              <a:buNone/>
-            </a:pPr>
-            <a:r>
-              <a:rPr lang="en-US" sz="1250" b="1" spc="100" kern="0" dirty="0">
+            <a:pPr marL="0" indent="0">
+              <a:buNone/>
+            </a:pPr>
+            <a:r>
+              <a:rPr lang="en-US" sz="1250" b="1" kern="0" spc="100" dirty="0">
                 <a:solidFill>
                   <a:srgbClr val="13263B"/>
                 </a:solidFill>
@@ -14807,7 +14616,7 @@
           <a:bodyPr wrap="square" lIns="0" tIns="0" rIns="0" bIns="0" rtlCol="0" anchor="ctr"/>
           <a:lstStyle/>
           <a:p>
-            <a:pPr indent="0" marL="0">
+            <a:pPr marL="0" indent="0">
               <a:buNone/>
             </a:pPr>
             <a:r>
@@ -14846,7 +14655,7 @@
           <a:bodyPr wrap="square" lIns="0" tIns="0" rIns="0" bIns="0" rtlCol="0" anchor="ctr"/>
           <a:lstStyle/>
           <a:p>
-            <a:pPr algn="r" indent="0" marL="0">
+            <a:pPr marL="0" indent="0" algn="r">
               <a:buNone/>
             </a:pPr>
             <a:r>
@@ -14885,7 +14694,7 @@
           <a:bodyPr wrap="square" lIns="0" tIns="0" rIns="0" bIns="0" rtlCol="0" anchor="ctr"/>
           <a:lstStyle/>
           <a:p>
-            <a:pPr indent="0" marL="0">
+            <a:pPr marL="0" indent="0">
               <a:buNone/>
             </a:pPr>
             <a:r>
@@ -14924,7 +14733,7 @@
           <a:bodyPr wrap="square" lIns="0" tIns="0" rIns="0" bIns="0" rtlCol="0" anchor="ctr"/>
           <a:lstStyle/>
           <a:p>
-            <a:pPr algn="r" indent="0" marL="0">
+            <a:pPr marL="0" indent="0" algn="r">
               <a:buNone/>
             </a:pPr>
             <a:r>
@@ -14963,7 +14772,7 @@
           <a:bodyPr wrap="square" lIns="0" tIns="0" rIns="0" bIns="0" rtlCol="0" anchor="ctr"/>
           <a:lstStyle/>
           <a:p>
-            <a:pPr indent="0" marL="0">
+            <a:pPr marL="0" indent="0">
               <a:buNone/>
             </a:pPr>
             <a:r>
@@ -15002,7 +14811,7 @@
           <a:bodyPr wrap="square" lIns="0" tIns="0" rIns="0" bIns="0" rtlCol="0" anchor="ctr"/>
           <a:lstStyle/>
           <a:p>
-            <a:pPr algn="r" indent="0" marL="0">
+            <a:pPr marL="0" indent="0" algn="r">
               <a:buNone/>
             </a:pPr>
             <a:r>
@@ -15041,7 +14850,7 @@
           <a:bodyPr wrap="square" lIns="0" tIns="0" rIns="0" bIns="0" rtlCol="0" anchor="ctr"/>
           <a:lstStyle/>
           <a:p>
-            <a:pPr indent="0" marL="0">
+            <a:pPr marL="0" indent="0">
               <a:buNone/>
             </a:pPr>
             <a:r>
@@ -15080,7 +14889,7 @@
           <a:bodyPr wrap="square" lIns="0" tIns="0" rIns="0" bIns="0" rtlCol="0" anchor="ctr"/>
           <a:lstStyle/>
           <a:p>
-            <a:pPr algn="r" indent="0" marL="0">
+            <a:pPr marL="0" indent="0" algn="r">
               <a:buNone/>
             </a:pPr>
             <a:r>
@@ -15119,7 +14928,7 @@
           <a:bodyPr wrap="square" lIns="0" tIns="0" rIns="0" bIns="0" rtlCol="0" anchor="ctr"/>
           <a:lstStyle/>
           <a:p>
-            <a:pPr indent="0" marL="0">
+            <a:pPr marL="0" indent="0">
               <a:buNone/>
             </a:pPr>
             <a:r>
@@ -15158,7 +14967,7 @@
           <a:bodyPr wrap="square" lIns="0" tIns="0" rIns="0" bIns="0" rtlCol="0" anchor="ctr"/>
           <a:lstStyle/>
           <a:p>
-            <a:pPr algn="r" indent="0" marL="0">
+            <a:pPr marL="0" indent="0" algn="r">
               <a:buNone/>
             </a:pPr>
             <a:r>
@@ -15197,7 +15006,7 @@
           <a:bodyPr wrap="square" lIns="0" tIns="0" rIns="0" bIns="0" rtlCol="0" anchor="ctr"/>
           <a:lstStyle/>
           <a:p>
-            <a:pPr indent="0" marL="0">
+            <a:pPr marL="0" indent="0">
               <a:buNone/>
             </a:pPr>
             <a:r>
@@ -15236,7 +15045,7 @@
           <a:bodyPr wrap="square" lIns="0" tIns="0" rIns="0" bIns="0" rtlCol="0" anchor="ctr"/>
           <a:lstStyle/>
           <a:p>
-            <a:pPr algn="r" indent="0" marL="0">
+            <a:pPr marL="0" indent="0" algn="r">
               <a:buNone/>
             </a:pPr>
             <a:r>
@@ -15275,11 +15084,11 @@
           <a:bodyPr wrap="square" lIns="0" tIns="0" rIns="0" bIns="0" rtlCol="0" anchor="ctr"/>
           <a:lstStyle/>
           <a:p>
-            <a:pPr indent="0" marL="0">
-              <a:buNone/>
-            </a:pPr>
-            <a:r>
-              <a:rPr lang="en-US" sz="1250" b="1" spc="100" kern="0" dirty="0">
+            <a:pPr marL="0" indent="0">
+              <a:buNone/>
+            </a:pPr>
+            <a:r>
+              <a:rPr lang="en-US" sz="1250" b="1" kern="0" spc="100" dirty="0">
                 <a:solidFill>
                   <a:srgbClr val="13263B"/>
                 </a:solidFill>
@@ -15314,7 +15123,7 @@
           </a:solidFill>
           <a:ln/>
           <a:effectLst>
-            <a:outerShdw sx="100000" sy="100000" kx="0" ky="0" algn="bl" rotWithShape="0" blurRad="101600" dist="38100" dir="5400000">
+            <a:outerShdw blurRad="101600" dist="38100" dir="5400000" algn="bl" rotWithShape="0">
               <a:srgbClr val="0A1626">
                 <a:alpha val="10000"/>
               </a:srgbClr>
@@ -15363,7 +15172,7 @@
           <a:bodyPr wrap="square" lIns="0" tIns="0" rIns="0" bIns="0" rtlCol="0" anchor="ctr"/>
           <a:lstStyle/>
           <a:p>
-            <a:pPr indent="0" marL="0">
+            <a:pPr marL="0" indent="0">
               <a:buNone/>
             </a:pPr>
             <a:r>
@@ -15402,7 +15211,7 @@
           <a:bodyPr wrap="square" lIns="0" tIns="0" rIns="0" bIns="0" rtlCol="0" anchor="ctr"/>
           <a:lstStyle/>
           <a:p>
-            <a:pPr algn="r" indent="0" marL="0">
+            <a:pPr marL="0" indent="0" algn="r">
               <a:buNone/>
             </a:pPr>
             <a:r>
@@ -15441,7 +15250,7 @@
           </a:solidFill>
           <a:ln/>
           <a:effectLst>
-            <a:outerShdw sx="100000" sy="100000" kx="0" ky="0" algn="bl" rotWithShape="0" blurRad="101600" dist="38100" dir="5400000">
+            <a:outerShdw blurRad="101600" dist="38100" dir="5400000" algn="bl" rotWithShape="0">
               <a:srgbClr val="0A1626">
                 <a:alpha val="10000"/>
               </a:srgbClr>
@@ -15490,7 +15299,7 @@
           <a:bodyPr wrap="square" lIns="0" tIns="0" rIns="0" bIns="0" rtlCol="0" anchor="ctr"/>
           <a:lstStyle/>
           <a:p>
-            <a:pPr indent="0" marL="0">
+            <a:pPr marL="0" indent="0">
               <a:buNone/>
             </a:pPr>
             <a:r>
@@ -15529,7 +15338,7 @@
           <a:bodyPr wrap="square" lIns="0" tIns="0" rIns="0" bIns="0" rtlCol="0" anchor="ctr"/>
           <a:lstStyle/>
           <a:p>
-            <a:pPr algn="r" indent="0" marL="0">
+            <a:pPr marL="0" indent="0" algn="r">
               <a:buNone/>
             </a:pPr>
             <a:r>
@@ -15568,7 +15377,7 @@
           </a:solidFill>
           <a:ln/>
           <a:effectLst>
-            <a:outerShdw sx="100000" sy="100000" kx="0" ky="0" algn="bl" rotWithShape="0" blurRad="101600" dist="38100" dir="5400000">
+            <a:outerShdw blurRad="101600" dist="38100" dir="5400000" algn="bl" rotWithShape="0">
               <a:srgbClr val="0A1626">
                 <a:alpha val="10000"/>
               </a:srgbClr>
@@ -15617,7 +15426,7 @@
           <a:bodyPr wrap="square" lIns="0" tIns="0" rIns="0" bIns="0" rtlCol="0" anchor="ctr"/>
           <a:lstStyle/>
           <a:p>
-            <a:pPr indent="0" marL="0">
+            <a:pPr marL="0" indent="0">
               <a:buNone/>
             </a:pPr>
             <a:r>
@@ -15656,7 +15465,7 @@
           <a:bodyPr wrap="square" lIns="0" tIns="0" rIns="0" bIns="0" rtlCol="0" anchor="ctr"/>
           <a:lstStyle/>
           <a:p>
-            <a:pPr algn="r" indent="0" marL="0">
+            <a:pPr marL="0" indent="0" algn="r">
               <a:buNone/>
             </a:pPr>
             <a:r>
@@ -15695,7 +15504,7 @@
           </a:solidFill>
           <a:ln/>
           <a:effectLst>
-            <a:outerShdw sx="100000" sy="100000" kx="0" ky="0" algn="bl" rotWithShape="0" blurRad="101600" dist="38100" dir="5400000">
+            <a:outerShdw blurRad="101600" dist="38100" dir="5400000" algn="bl" rotWithShape="0">
               <a:srgbClr val="0A1626">
                 <a:alpha val="10000"/>
               </a:srgbClr>
@@ -15744,7 +15553,7 @@
           <a:bodyPr wrap="square" lIns="0" tIns="0" rIns="0" bIns="0" rtlCol="0" anchor="ctr"/>
           <a:lstStyle/>
           <a:p>
-            <a:pPr indent="0" marL="0">
+            <a:pPr marL="0" indent="0">
               <a:buNone/>
             </a:pPr>
             <a:r>
@@ -15783,7 +15592,7 @@
           <a:bodyPr wrap="square" lIns="0" tIns="0" rIns="0" bIns="0" rtlCol="0" anchor="ctr"/>
           <a:lstStyle/>
           <a:p>
-            <a:pPr algn="r" indent="0" marL="0">
+            <a:pPr marL="0" indent="0" algn="r">
               <a:buNone/>
             </a:pPr>
             <a:r>
@@ -15822,7 +15631,7 @@
           <a:bodyPr wrap="square" lIns="0" tIns="0" rIns="0" bIns="0" rtlCol="0" anchor="ctr"/>
           <a:lstStyle/>
           <a:p>
-            <a:pPr indent="0" marL="0">
+            <a:pPr marL="0" indent="0">
               <a:buNone/>
             </a:pPr>
             <a:r>
@@ -15836,9 +15645,6 @@
               </a:rPr>
               <a:t>SeaWatch</a:t>
             </a:r>
-            <a:pPr indent="0" marL="0">
-              <a:buNone/>
-            </a:pPr>
             <a:r>
               <a:rPr lang="en-US" sz="900" dirty="0">
                 <a:solidFill>
@@ -15875,7 +15681,7 @@
           <a:bodyPr wrap="square" rtlCol="0" anchor="ctr"/>
           <a:lstStyle/>
           <a:p>
-            <a:pPr algn="r" indent="0" marL="0">
+            <a:pPr marL="0" indent="0" algn="r">
               <a:buNone/>
             </a:pPr>
             <a:r>
@@ -15909,6 +15715,7 @@
         <a:solidFill>
           <a:srgbClr val="FFFFFF"/>
         </a:solidFill>
+        <a:effectLst/>
       </p:bgPr>
     </p:bg>
     <p:spTree>
@@ -15946,11 +15753,11 @@
           <a:bodyPr wrap="square" lIns="0" tIns="0" rIns="0" bIns="0" rtlCol="0" anchor="ctr"/>
           <a:lstStyle/>
           <a:p>
-            <a:pPr indent="0" marL="0">
-              <a:buNone/>
-            </a:pPr>
-            <a:r>
-              <a:rPr lang="en-US" sz="1250" b="1" spc="200" kern="0" dirty="0">
+            <a:pPr marL="0" indent="0">
+              <a:buNone/>
+            </a:pPr>
+            <a:r>
+              <a:rPr lang="en-US" sz="1250" b="1" kern="0" spc="200" dirty="0">
                 <a:solidFill>
                   <a:srgbClr val="0B7A3B"/>
                 </a:solidFill>
@@ -15985,7 +15792,7 @@
           <a:bodyPr wrap="square" lIns="0" tIns="0" rIns="0" bIns="0" rtlCol="0" anchor="ctr"/>
           <a:lstStyle/>
           <a:p>
-            <a:pPr indent="0" marL="0">
+            <a:pPr marL="0" indent="0">
               <a:buNone/>
             </a:pPr>
             <a:r>
@@ -16024,7 +15831,7 @@
           <a:bodyPr wrap="square" lIns="0" tIns="0" rIns="0" bIns="0" rtlCol="0" anchor="ctr"/>
           <a:lstStyle/>
           <a:p>
-            <a:pPr indent="0" marL="0">
+            <a:pPr marL="0" indent="0">
               <a:buNone/>
             </a:pPr>
             <a:r>
@@ -16063,11 +15870,11 @@
           <a:bodyPr wrap="square" lIns="0" tIns="0" rIns="0" bIns="0" rtlCol="0" anchor="ctr"/>
           <a:lstStyle/>
           <a:p>
-            <a:pPr indent="0" marL="0">
-              <a:buNone/>
-            </a:pPr>
-            <a:r>
-              <a:rPr lang="en-US" sz="1150" b="1" spc="100" kern="0" dirty="0">
+            <a:pPr marL="0" indent="0">
+              <a:buNone/>
+            </a:pPr>
+            <a:r>
+              <a:rPr lang="en-US" sz="1150" b="1" kern="0" spc="100" dirty="0">
                 <a:solidFill>
                   <a:srgbClr val="5C6E82"/>
                 </a:solidFill>
@@ -16102,7 +15909,7 @@
           </a:solidFill>
           <a:ln/>
           <a:effectLst>
-            <a:outerShdw sx="100000" sy="100000" kx="0" ky="0" algn="bl" rotWithShape="0" blurRad="101600" dist="38100" dir="5400000">
+            <a:outerShdw blurRad="101600" dist="38100" dir="5400000" algn="bl" rotWithShape="0">
               <a:srgbClr val="0A1626">
                 <a:alpha val="10000"/>
               </a:srgbClr>
@@ -16151,7 +15958,7 @@
           <a:bodyPr wrap="square" lIns="0" tIns="0" rIns="0" bIns="0" rtlCol="0" anchor="ctr"/>
           <a:lstStyle/>
           <a:p>
-            <a:pPr indent="0" marL="0">
+            <a:pPr marL="0" indent="0">
               <a:buNone/>
             </a:pPr>
             <a:r>
@@ -16190,7 +15997,7 @@
           </a:solidFill>
           <a:ln/>
           <a:effectLst>
-            <a:outerShdw sx="100000" sy="100000" kx="0" ky="0" algn="bl" rotWithShape="0" blurRad="101600" dist="38100" dir="5400000">
+            <a:outerShdw blurRad="101600" dist="38100" dir="5400000" algn="bl" rotWithShape="0">
               <a:srgbClr val="0A1626">
                 <a:alpha val="10000"/>
               </a:srgbClr>
@@ -16239,7 +16046,7 @@
           <a:bodyPr wrap="square" lIns="0" tIns="0" rIns="0" bIns="0" rtlCol="0" anchor="ctr"/>
           <a:lstStyle/>
           <a:p>
-            <a:pPr indent="0" marL="0">
+            <a:pPr marL="0" indent="0">
               <a:buNone/>
             </a:pPr>
             <a:r>
@@ -16278,7 +16085,7 @@
           </a:solidFill>
           <a:ln/>
           <a:effectLst>
-            <a:outerShdw sx="100000" sy="100000" kx="0" ky="0" algn="bl" rotWithShape="0" blurRad="101600" dist="38100" dir="5400000">
+            <a:outerShdw blurRad="101600" dist="38100" dir="5400000" algn="bl" rotWithShape="0">
               <a:srgbClr val="0A1626">
                 <a:alpha val="10000"/>
               </a:srgbClr>
@@ -16327,7 +16134,7 @@
           <a:bodyPr wrap="square" lIns="0" tIns="0" rIns="0" bIns="0" rtlCol="0" anchor="ctr"/>
           <a:lstStyle/>
           <a:p>
-            <a:pPr indent="0" marL="0">
+            <a:pPr marL="0" indent="0">
               <a:buNone/>
             </a:pPr>
             <a:r>
@@ -16366,7 +16173,7 @@
           </a:solidFill>
           <a:ln/>
           <a:effectLst>
-            <a:outerShdw sx="100000" sy="100000" kx="0" ky="0" algn="bl" rotWithShape="0" blurRad="101600" dist="38100" dir="5400000">
+            <a:outerShdw blurRad="101600" dist="38100" dir="5400000" algn="bl" rotWithShape="0">
               <a:srgbClr val="0A1626">
                 <a:alpha val="10000"/>
               </a:srgbClr>
@@ -16415,7 +16222,7 @@
           <a:bodyPr wrap="square" lIns="0" tIns="0" rIns="0" bIns="0" rtlCol="0" anchor="ctr"/>
           <a:lstStyle/>
           <a:p>
-            <a:pPr indent="0" marL="0">
+            <a:pPr marL="0" indent="0">
               <a:buNone/>
             </a:pPr>
             <a:r>
@@ -16454,7 +16261,7 @@
           </a:solidFill>
           <a:ln/>
           <a:effectLst>
-            <a:outerShdw sx="100000" sy="100000" kx="0" ky="0" algn="bl" rotWithShape="0" blurRad="101600" dist="38100" dir="5400000">
+            <a:outerShdw blurRad="101600" dist="38100" dir="5400000" algn="bl" rotWithShape="0">
               <a:srgbClr val="0A1626">
                 <a:alpha val="10000"/>
               </a:srgbClr>
@@ -16503,7 +16310,7 @@
           <a:bodyPr wrap="square" lIns="0" tIns="0" rIns="0" bIns="0" rtlCol="0" anchor="ctr"/>
           <a:lstStyle/>
           <a:p>
-            <a:pPr indent="0" marL="0">
+            <a:pPr marL="0" indent="0">
               <a:buNone/>
             </a:pPr>
             <a:r>
@@ -16542,7 +16349,7 @@
           </a:solidFill>
           <a:ln/>
           <a:effectLst>
-            <a:outerShdw sx="100000" sy="100000" kx="0" ky="0" algn="bl" rotWithShape="0" blurRad="101600" dist="38100" dir="5400000">
+            <a:outerShdw blurRad="101600" dist="38100" dir="5400000" algn="bl" rotWithShape="0">
               <a:srgbClr val="0A1626">
                 <a:alpha val="10000"/>
               </a:srgbClr>
@@ -16591,7 +16398,7 @@
           <a:bodyPr wrap="square" lIns="0" tIns="0" rIns="0" bIns="0" rtlCol="0" anchor="ctr"/>
           <a:lstStyle/>
           <a:p>
-            <a:pPr indent="0" marL="0">
+            <a:pPr marL="0" indent="0">
               <a:buNone/>
             </a:pPr>
             <a:r>
@@ -16630,7 +16437,7 @@
           </a:solidFill>
           <a:ln/>
           <a:effectLst>
-            <a:outerShdw sx="100000" sy="100000" kx="0" ky="0" algn="bl" rotWithShape="0" blurRad="101600" dist="38100" dir="5400000">
+            <a:outerShdw blurRad="101600" dist="38100" dir="5400000" algn="bl" rotWithShape="0">
               <a:srgbClr val="0A1626">
                 <a:alpha val="10000"/>
               </a:srgbClr>
@@ -16679,7 +16486,7 @@
           <a:bodyPr wrap="square" lIns="0" tIns="0" rIns="0" bIns="0" rtlCol="0" anchor="ctr"/>
           <a:lstStyle/>
           <a:p>
-            <a:pPr indent="0" marL="0">
+            <a:pPr marL="0" indent="0">
               <a:buNone/>
             </a:pPr>
             <a:r>
@@ -16718,7 +16525,7 @@
           </a:solidFill>
           <a:ln/>
           <a:effectLst>
-            <a:outerShdw sx="100000" sy="100000" kx="0" ky="0" algn="bl" rotWithShape="0" blurRad="101600" dist="38100" dir="5400000">
+            <a:outerShdw blurRad="101600" dist="38100" dir="5400000" algn="bl" rotWithShape="0">
               <a:srgbClr val="0A1626">
                 <a:alpha val="10000"/>
               </a:srgbClr>
@@ -16767,7 +16574,7 @@
           <a:bodyPr wrap="square" lIns="0" tIns="0" rIns="0" bIns="0" rtlCol="0" anchor="ctr"/>
           <a:lstStyle/>
           <a:p>
-            <a:pPr indent="0" marL="0">
+            <a:pPr marL="0" indent="0">
               <a:buNone/>
             </a:pPr>
             <a:r>
@@ -16806,7 +16613,7 @@
           </a:solidFill>
           <a:ln/>
           <a:effectLst>
-            <a:outerShdw sx="100000" sy="100000" kx="0" ky="0" algn="bl" rotWithShape="0" blurRad="101600" dist="38100" dir="5400000">
+            <a:outerShdw blurRad="101600" dist="38100" dir="5400000" algn="bl" rotWithShape="0">
               <a:srgbClr val="0A1626">
                 <a:alpha val="10000"/>
               </a:srgbClr>
@@ -16855,7 +16662,7 @@
           <a:bodyPr wrap="square" lIns="0" tIns="0" rIns="0" bIns="0" rtlCol="0" anchor="ctr"/>
           <a:lstStyle/>
           <a:p>
-            <a:pPr indent="0" marL="0">
+            <a:pPr marL="0" indent="0">
               <a:buNone/>
             </a:pPr>
             <a:r>
@@ -16894,7 +16701,7 @@
           </a:solidFill>
           <a:ln/>
           <a:effectLst>
-            <a:outerShdw sx="100000" sy="100000" kx="0" ky="0" algn="bl" rotWithShape="0" blurRad="101600" dist="38100" dir="5400000">
+            <a:outerShdw blurRad="101600" dist="38100" dir="5400000" algn="bl" rotWithShape="0">
               <a:srgbClr val="0A1626">
                 <a:alpha val="10000"/>
               </a:srgbClr>
@@ -16923,7 +16730,7 @@
           <a:bodyPr wrap="square" lIns="0" tIns="0" rIns="0" bIns="0" rtlCol="0" anchor="ctr"/>
           <a:lstStyle/>
           <a:p>
-            <a:pPr indent="0" marL="0">
+            <a:pPr marL="0" indent="0">
               <a:buNone/>
             </a:pPr>
             <a:r>
@@ -16962,7 +16769,7 @@
           <a:bodyPr wrap="square" lIns="0" tIns="0" rIns="0" bIns="0" rtlCol="0" anchor="t"/>
           <a:lstStyle/>
           <a:p>
-            <a:pPr indent="0" marL="0">
+            <a:pPr marL="0" indent="0">
               <a:buNone/>
             </a:pPr>
             <a:r>
@@ -17001,7 +16808,7 @@
           </a:solidFill>
           <a:ln/>
           <a:effectLst>
-            <a:outerShdw sx="100000" sy="100000" kx="0" ky="0" algn="bl" rotWithShape="0" blurRad="101600" dist="38100" dir="5400000">
+            <a:outerShdw blurRad="101600" dist="38100" dir="5400000" algn="bl" rotWithShape="0">
               <a:srgbClr val="0A1626">
                 <a:alpha val="10000"/>
               </a:srgbClr>
@@ -17030,7 +16837,7 @@
           <a:bodyPr wrap="square" lIns="0" tIns="0" rIns="0" bIns="0" rtlCol="0" anchor="ctr"/>
           <a:lstStyle/>
           <a:p>
-            <a:pPr indent="0" marL="0">
+            <a:pPr marL="0" indent="0">
               <a:buNone/>
             </a:pPr>
             <a:r>
@@ -17069,7 +16876,7 @@
           <a:bodyPr wrap="square" lIns="0" tIns="0" rIns="0" bIns="0" rtlCol="0" anchor="t"/>
           <a:lstStyle/>
           <a:p>
-            <a:pPr indent="0" marL="0">
+            <a:pPr marL="0" indent="0">
               <a:buNone/>
             </a:pPr>
             <a:r>
@@ -17108,7 +16915,7 @@
           </a:solidFill>
           <a:ln/>
           <a:effectLst>
-            <a:outerShdw sx="100000" sy="100000" kx="0" ky="0" algn="bl" rotWithShape="0" blurRad="101600" dist="38100" dir="5400000">
+            <a:outerShdw blurRad="101600" dist="38100" dir="5400000" algn="bl" rotWithShape="0">
               <a:srgbClr val="0A1626">
                 <a:alpha val="10000"/>
               </a:srgbClr>
@@ -17137,7 +16944,7 @@
           <a:bodyPr wrap="square" lIns="0" tIns="0" rIns="0" bIns="0" rtlCol="0" anchor="ctr"/>
           <a:lstStyle/>
           <a:p>
-            <a:pPr indent="0" marL="0">
+            <a:pPr marL="0" indent="0">
               <a:buNone/>
             </a:pPr>
             <a:r>
@@ -17176,7 +16983,7 @@
           <a:bodyPr wrap="square" lIns="0" tIns="0" rIns="0" bIns="0" rtlCol="0" anchor="t"/>
           <a:lstStyle/>
           <a:p>
-            <a:pPr indent="0" marL="0">
+            <a:pPr marL="0" indent="0">
               <a:buNone/>
             </a:pPr>
             <a:r>
@@ -17215,7 +17022,7 @@
           <a:bodyPr wrap="square" lIns="0" tIns="0" rIns="0" bIns="0" rtlCol="0" anchor="ctr"/>
           <a:lstStyle/>
           <a:p>
-            <a:pPr indent="0" marL="0">
+            <a:pPr marL="0" indent="0">
               <a:buNone/>
             </a:pPr>
             <a:r>
@@ -17229,9 +17036,6 @@
               </a:rPr>
               <a:t>SeaWatch</a:t>
             </a:r>
-            <a:pPr indent="0" marL="0">
-              <a:buNone/>
-            </a:pPr>
             <a:r>
               <a:rPr lang="en-US" sz="900" dirty="0">
                 <a:solidFill>
@@ -17268,7 +17072,7 @@
           <a:bodyPr wrap="square" rtlCol="0" anchor="ctr"/>
           <a:lstStyle/>
           <a:p>
-            <a:pPr algn="r" indent="0" marL="0">
+            <a:pPr marL="0" indent="0" algn="r">
               <a:buNone/>
             </a:pPr>
             <a:r>
@@ -17587,4 +17391,265 @@
     </a:ext>
   </a:extLst>
 </a:theme>
+</file>
+
+<file path=ppt/theme/theme2.xml><?xml version="1.0" encoding="utf-8"?>
+<a:theme xmlns:a="http://schemas.openxmlformats.org/drawingml/2006/main" name="Office Theme">
+  <a:themeElements>
+    <a:clrScheme name="Office">
+      <a:dk1>
+        <a:sysClr val="windowText" lastClr="000000"/>
+      </a:dk1>
+      <a:lt1>
+        <a:sysClr val="window" lastClr="FFFFFF"/>
+      </a:lt1>
+      <a:dk2>
+        <a:srgbClr val="44546A"/>
+      </a:dk2>
+      <a:lt2>
+        <a:srgbClr val="E7E6E6"/>
+      </a:lt2>
+      <a:accent1>
+        <a:srgbClr val="5B9BD5"/>
+      </a:accent1>
+      <a:accent2>
+        <a:srgbClr val="ED7D31"/>
+      </a:accent2>
+      <a:accent3>
+        <a:srgbClr val="A5A5A5"/>
+      </a:accent3>
+      <a:accent4>
+        <a:srgbClr val="FFC000"/>
+      </a:accent4>
+      <a:accent5>
+        <a:srgbClr val="4472C4"/>
+      </a:accent5>
+      <a:accent6>
+        <a:srgbClr val="70AD47"/>
+      </a:accent6>
+      <a:hlink>
+        <a:srgbClr val="0563C1"/>
+      </a:hlink>
+      <a:folHlink>
+        <a:srgbClr val="954F72"/>
+      </a:folHlink>
+    </a:clrScheme>
+    <a:fontScheme name="Office">
+      <a:majorFont>
+        <a:latin typeface="Calibri Light" panose="020F0302020204030204"/>
+        <a:ea typeface=""/>
+        <a:cs typeface=""/>
+        <a:font script="Jpan" typeface="游ゴシック Light"/>
+        <a:font script="Hang" typeface="맑은 고딕"/>
+        <a:font script="Hans" typeface="等线 Light"/>
+        <a:font script="Hant" typeface="新細明體"/>
+        <a:font script="Arab" typeface="Times New Roman"/>
+        <a:font script="Hebr" typeface="Times New Roman"/>
+        <a:font script="Thai" typeface="Angsana New"/>
+        <a:font script="Ethi" typeface="Nyala"/>
+        <a:font script="Beng" typeface="Vrinda"/>
+        <a:font script="Gujr" typeface="Shruti"/>
+        <a:font script="Khmr" typeface="MoolBoran"/>
+        <a:font script="Knda" typeface="Tunga"/>
+        <a:font script="Guru" typeface="Raavi"/>
+        <a:font script="Cans" typeface="Euphemia"/>
+        <a:font script="Cher" typeface="Plantagenet Cherokee"/>
+        <a:font script="Yiii" typeface="Microsoft Yi Baiti"/>
+        <a:font script="Tibt" typeface="Microsoft Himalaya"/>
+        <a:font script="Thaa" typeface="MV Boli"/>
+        <a:font script="Deva" typeface="Mangal"/>
+        <a:font script="Telu" typeface="Gautami"/>
+        <a:font script="Taml" typeface="Latha"/>
+        <a:font script="Syrc" typeface="Estrangelo Edessa"/>
+        <a:font script="Orya" typeface="Kalinga"/>
+        <a:font script="Mlym" typeface="Kartika"/>
+        <a:font script="Laoo" typeface="DokChampa"/>
+        <a:font script="Sinh" typeface="Iskoola Pota"/>
+        <a:font script="Mong" typeface="Mongolian Baiti"/>
+        <a:font script="Viet" typeface="Times New Roman"/>
+        <a:font script="Uigh" typeface="Microsoft Uighur"/>
+        <a:font script="Geor" typeface="Sylfaen"/>
+      </a:majorFont>
+      <a:minorFont>
+        <a:latin typeface="Calibri" panose="020F0502020204030204"/>
+        <a:ea typeface=""/>
+        <a:cs typeface=""/>
+        <a:font script="Jpan" typeface="游ゴシック"/>
+        <a:font script="Hang" typeface="맑은 고딕"/>
+        <a:font script="Hans" typeface="等线"/>
+        <a:font script="Hant" typeface="新細明體"/>
+        <a:font script="Arab" typeface="Arial"/>
+        <a:font script="Hebr" typeface="Arial"/>
+        <a:font script="Thai" typeface="Cordia New"/>
+        <a:font script="Ethi" typeface="Nyala"/>
+        <a:font script="Beng" typeface="Vrinda"/>
+        <a:font script="Gujr" typeface="Shruti"/>
+        <a:font script="Khmr" typeface="DaunPenh"/>
+        <a:font script="Knda" typeface="Tunga"/>
+        <a:font script="Guru" typeface="Raavi"/>
+        <a:font script="Cans" typeface="Euphemia"/>
+        <a:font script="Cher" typeface="Plantagenet Cherokee"/>
+        <a:font script="Yiii" typeface="Microsoft Yi Baiti"/>
+        <a:font script="Tibt" typeface="Microsoft Himalaya"/>
+        <a:font script="Thaa" typeface="MV Boli"/>
+        <a:font script="Deva" typeface="Mangal"/>
+        <a:font script="Telu" typeface="Gautami"/>
+        <a:font script="Taml" typeface="Latha"/>
+        <a:font script="Syrc" typeface="Estrangelo Edessa"/>
+        <a:font script="Orya" typeface="Kalinga"/>
+        <a:font script="Mlym" typeface="Kartika"/>
+        <a:font script="Laoo" typeface="DokChampa"/>
+        <a:font script="Sinh" typeface="Iskoola Pota"/>
+        <a:font script="Mong" typeface="Mongolian Baiti"/>
+        <a:font script="Viet" typeface="Arial"/>
+        <a:font script="Uigh" typeface="Microsoft Uighur"/>
+        <a:font script="Geor" typeface="Sylfaen"/>
+      </a:minorFont>
+    </a:fontScheme>
+    <a:fmtScheme name="Office">
+      <a:fillStyleLst>
+        <a:solidFill>
+          <a:schemeClr val="phClr"/>
+        </a:solidFill>
+        <a:gradFill rotWithShape="1">
+          <a:gsLst>
+            <a:gs pos="0">
+              <a:schemeClr val="phClr">
+                <a:lumMod val="110000"/>
+                <a:satMod val="105000"/>
+                <a:tint val="67000"/>
+              </a:schemeClr>
+            </a:gs>
+            <a:gs pos="50000">
+              <a:schemeClr val="phClr">
+                <a:lumMod val="105000"/>
+                <a:satMod val="103000"/>
+                <a:tint val="73000"/>
+              </a:schemeClr>
+            </a:gs>
+            <a:gs pos="100000">
+              <a:schemeClr val="phClr">
+                <a:lumMod val="105000"/>
+                <a:satMod val="109000"/>
+                <a:tint val="81000"/>
+              </a:schemeClr>
+            </a:gs>
+          </a:gsLst>
+          <a:lin ang="5400000" scaled="0"/>
+        </a:gradFill>
+        <a:gradFill rotWithShape="1">
+          <a:gsLst>
+            <a:gs pos="0">
+              <a:schemeClr val="phClr">
+                <a:satMod val="103000"/>
+                <a:lumMod val="102000"/>
+                <a:tint val="94000"/>
+              </a:schemeClr>
+            </a:gs>
+            <a:gs pos="50000">
+              <a:schemeClr val="phClr">
+                <a:satMod val="110000"/>
+                <a:lumMod val="100000"/>
+                <a:shade val="100000"/>
+              </a:schemeClr>
+            </a:gs>
+            <a:gs pos="100000">
+              <a:schemeClr val="phClr">
+                <a:lumMod val="99000"/>
+                <a:satMod val="120000"/>
+                <a:shade val="78000"/>
+              </a:schemeClr>
+            </a:gs>
+          </a:gsLst>
+          <a:lin ang="5400000" scaled="0"/>
+        </a:gradFill>
+      </a:fillStyleLst>
+      <a:lnStyleLst>
+        <a:ln w="6350" cap="flat" cmpd="sng" algn="ctr">
+          <a:solidFill>
+            <a:schemeClr val="phClr"/>
+          </a:solidFill>
+          <a:prstDash val="solid"/>
+          <a:miter lim="800000"/>
+        </a:ln>
+        <a:ln w="12700" cap="flat" cmpd="sng" algn="ctr">
+          <a:solidFill>
+            <a:schemeClr val="phClr"/>
+          </a:solidFill>
+          <a:prstDash val="solid"/>
+          <a:miter lim="800000"/>
+        </a:ln>
+        <a:ln w="19050" cap="flat" cmpd="sng" algn="ctr">
+          <a:solidFill>
+            <a:schemeClr val="phClr"/>
+          </a:solidFill>
+          <a:prstDash val="solid"/>
+          <a:miter lim="800000"/>
+        </a:ln>
+      </a:lnStyleLst>
+      <a:effectStyleLst>
+        <a:effectStyle>
+          <a:effectLst/>
+        </a:effectStyle>
+        <a:effectStyle>
+          <a:effectLst/>
+        </a:effectStyle>
+        <a:effectStyle>
+          <a:effectLst>
+            <a:outerShdw blurRad="57150" dist="19050" dir="5400000" algn="ctr" rotWithShape="0">
+              <a:srgbClr val="000000">
+                <a:alpha val="63000"/>
+              </a:srgbClr>
+            </a:outerShdw>
+          </a:effectLst>
+        </a:effectStyle>
+      </a:effectStyleLst>
+      <a:bgFillStyleLst>
+        <a:solidFill>
+          <a:schemeClr val="phClr"/>
+        </a:solidFill>
+        <a:solidFill>
+          <a:schemeClr val="phClr">
+            <a:tint val="95000"/>
+            <a:satMod val="170000"/>
+          </a:schemeClr>
+        </a:solidFill>
+        <a:gradFill rotWithShape="1">
+          <a:gsLst>
+            <a:gs pos="0">
+              <a:schemeClr val="phClr">
+                <a:tint val="93000"/>
+                <a:satMod val="150000"/>
+                <a:shade val="98000"/>
+                <a:lumMod val="102000"/>
+              </a:schemeClr>
+            </a:gs>
+            <a:gs pos="50000">
+              <a:schemeClr val="phClr">
+                <a:tint val="98000"/>
+                <a:satMod val="130000"/>
+                <a:shade val="90000"/>
+                <a:lumMod val="103000"/>
+              </a:schemeClr>
+            </a:gs>
+            <a:gs pos="100000">
+              <a:schemeClr val="phClr">
+                <a:shade val="63000"/>
+                <a:satMod val="120000"/>
+              </a:schemeClr>
+            </a:gs>
+          </a:gsLst>
+          <a:lin ang="5400000" scaled="0"/>
+        </a:gradFill>
+      </a:bgFillStyleLst>
+    </a:fmtScheme>
+  </a:themeElements>
+  <a:objectDefaults/>
+  <a:extraClrSchemeLst/>
+  <a:extLst>
+    <a:ext uri="{05A4C25C-085E-4340-85A3-A5531E510DB2}">
+      <thm15:themeFamily xmlns:thm15="http://schemas.microsoft.com/office/thememl/2012/main" name="Office Theme" id="{62F939B6-93AF-4DB8-9C6B-D6C7DFDC589F}" vid="{4A3C46E8-61CC-4603-A589-7422A47A8E4A}"/>
+    </a:ext>
+  </a:extLst>
+</a:theme>
 </file>
</xml_diff>

<commit_message>
Replace CARTO dark basemap (now key-gated) with Esri Dark Gray Canvas
CARTO began requiring an API key for its free basemaps and stamps 'API KEY REQUIRED' across every tile, which was defacing the tactical map. Switched the dark basemap to Esri Dark Gray Canvas — no key, same provider as the existing satellite/ocean layers. Also set per-service maxNativeZoom (dark 16, satellite 19, ocean 13) so zooming past a service's published depth upscales tiles instead of rendering blank. Verified: tiles now served only from arcgisonline, all tiles load, 90 targets render.

Co-Authored-By: Claude Fable 5 <noreply@anthropic.com>
</commit_message>
<xml_diff>
--- a/SeaWatch-Capabilities-Brief.pptx
+++ b/SeaWatch-Capabilities-Brief.pptx
@@ -15223,7 +15223,18 @@
                 <a:ea typeface="Cambria" pitchFamily="34" charset="-122"/>
                 <a:cs typeface="Cambria" pitchFamily="34" charset="-120"/>
               </a:rPr>
-              <a:t>70 – 100</a:t>
+              <a:t>70 </a:t>
+            </a:r>
+            <a:r>
+              <a:rPr lang="en-US" sz="1400" b="1" dirty="0" smtClean="0">
+                <a:solidFill>
+                  <a:srgbClr val="C8102E"/>
+                </a:solidFill>
+                <a:latin typeface="Cambria" pitchFamily="34" charset="0"/>
+                <a:ea typeface="Cambria" pitchFamily="34" charset="-122"/>
+                <a:cs typeface="Cambria" pitchFamily="34" charset="-120"/>
+              </a:rPr>
+              <a:t>+</a:t>
             </a:r>
             <a:endParaRPr lang="en-US" sz="1400" dirty="0"/>
           </a:p>

</xml_diff>